<commit_message>
Added presentation to asset/docs
</commit_message>
<xml_diff>
--- a/pawpal_plus_ai_assistant/assets/docs/applied-ai-project.pptx
+++ b/pawpal_plus_ai_assistant/assets/docs/applied-ai-project.pptx
@@ -6,6 +6,12 @@
   </p:sldMasterIdLst>
   <p:sldIdLst>
     <p:sldId id="256" r:id="rId2"/>
+    <p:sldId id="257" r:id="rId3"/>
+    <p:sldId id="258" r:id="rId4"/>
+    <p:sldId id="259" r:id="rId5"/>
+    <p:sldId id="260" r:id="rId6"/>
+    <p:sldId id="261" r:id="rId7"/>
+    <p:sldId id="262" r:id="rId8"/>
   </p:sldIdLst>
   <p:sldSz cx="12192000" cy="6858000"/>
   <p:notesSz cx="6858000" cy="9144000"/>
@@ -104,6 +110,11 @@
       </a:defRPr>
     </a:lvl9pPr>
   </p:defaultTextStyle>
+  <p:extLst>
+    <p:ext uri="{EFAFB233-063F-42B5-8137-9DF3F51BA10A}">
+      <p15:sldGuideLst xmlns:p15="http://schemas.microsoft.com/office/powerpoint/2012/main"/>
+    </p:ext>
+  </p:extLst>
 </p:presentation>
 </file>
 
@@ -254,7 +265,7 @@
           <a:p>
             <a:fld id="{14C61D0E-13B9-4140-BEC5-3C5E6B49CAE6}" type="datetimeFigureOut">
               <a:rPr lang="en-US" smtClean="0"/>
-              <a:t>4/25/26</a:t>
+              <a:t>4/26/26</a:t>
             </a:fld>
             <a:endParaRPr lang="en-US"/>
           </a:p>
@@ -452,7 +463,7 @@
           <a:p>
             <a:fld id="{14C61D0E-13B9-4140-BEC5-3C5E6B49CAE6}" type="datetimeFigureOut">
               <a:rPr lang="en-US" smtClean="0"/>
-              <a:t>4/25/26</a:t>
+              <a:t>4/26/26</a:t>
             </a:fld>
             <a:endParaRPr lang="en-US"/>
           </a:p>
@@ -660,7 +671,7 @@
           <a:p>
             <a:fld id="{14C61D0E-13B9-4140-BEC5-3C5E6B49CAE6}" type="datetimeFigureOut">
               <a:rPr lang="en-US" smtClean="0"/>
-              <a:t>4/25/26</a:t>
+              <a:t>4/26/26</a:t>
             </a:fld>
             <a:endParaRPr lang="en-US"/>
           </a:p>
@@ -858,7 +869,7 @@
           <a:p>
             <a:fld id="{14C61D0E-13B9-4140-BEC5-3C5E6B49CAE6}" type="datetimeFigureOut">
               <a:rPr lang="en-US" smtClean="0"/>
-              <a:t>4/25/26</a:t>
+              <a:t>4/26/26</a:t>
             </a:fld>
             <a:endParaRPr lang="en-US"/>
           </a:p>
@@ -1133,7 +1144,7 @@
           <a:p>
             <a:fld id="{14C61D0E-13B9-4140-BEC5-3C5E6B49CAE6}" type="datetimeFigureOut">
               <a:rPr lang="en-US" smtClean="0"/>
-              <a:t>4/25/26</a:t>
+              <a:t>4/26/26</a:t>
             </a:fld>
             <a:endParaRPr lang="en-US"/>
           </a:p>
@@ -1398,7 +1409,7 @@
           <a:p>
             <a:fld id="{14C61D0E-13B9-4140-BEC5-3C5E6B49CAE6}" type="datetimeFigureOut">
               <a:rPr lang="en-US" smtClean="0"/>
-              <a:t>4/25/26</a:t>
+              <a:t>4/26/26</a:t>
             </a:fld>
             <a:endParaRPr lang="en-US"/>
           </a:p>
@@ -1810,7 +1821,7 @@
           <a:p>
             <a:fld id="{14C61D0E-13B9-4140-BEC5-3C5E6B49CAE6}" type="datetimeFigureOut">
               <a:rPr lang="en-US" smtClean="0"/>
-              <a:t>4/25/26</a:t>
+              <a:t>4/26/26</a:t>
             </a:fld>
             <a:endParaRPr lang="en-US"/>
           </a:p>
@@ -1951,7 +1962,7 @@
           <a:p>
             <a:fld id="{14C61D0E-13B9-4140-BEC5-3C5E6B49CAE6}" type="datetimeFigureOut">
               <a:rPr lang="en-US" smtClean="0"/>
-              <a:t>4/25/26</a:t>
+              <a:t>4/26/26</a:t>
             </a:fld>
             <a:endParaRPr lang="en-US"/>
           </a:p>
@@ -2064,7 +2075,7 @@
           <a:p>
             <a:fld id="{14C61D0E-13B9-4140-BEC5-3C5E6B49CAE6}" type="datetimeFigureOut">
               <a:rPr lang="en-US" smtClean="0"/>
-              <a:t>4/25/26</a:t>
+              <a:t>4/26/26</a:t>
             </a:fld>
             <a:endParaRPr lang="en-US"/>
           </a:p>
@@ -2375,7 +2386,7 @@
           <a:p>
             <a:fld id="{14C61D0E-13B9-4140-BEC5-3C5E6B49CAE6}" type="datetimeFigureOut">
               <a:rPr lang="en-US" smtClean="0"/>
-              <a:t>4/25/26</a:t>
+              <a:t>4/26/26</a:t>
             </a:fld>
             <a:endParaRPr lang="en-US"/>
           </a:p>
@@ -2663,7 +2674,7 @@
           <a:p>
             <a:fld id="{14C61D0E-13B9-4140-BEC5-3C5E6B49CAE6}" type="datetimeFigureOut">
               <a:rPr lang="en-US" smtClean="0"/>
-              <a:t>4/25/26</a:t>
+              <a:t>4/26/26</a:t>
             </a:fld>
             <a:endParaRPr lang="en-US"/>
           </a:p>
@@ -2904,7 +2915,7 @@
           <a:p>
             <a:fld id="{14C61D0E-13B9-4140-BEC5-3C5E6B49CAE6}" type="datetimeFigureOut">
               <a:rPr lang="en-US" smtClean="0"/>
-              <a:t>4/25/26</a:t>
+              <a:t>4/26/26</a:t>
             </a:fld>
             <a:endParaRPr lang="en-US"/>
           </a:p>
@@ -3345,7 +3356,7 @@
         </p:blipFill>
         <p:spPr>
           <a:xfrm>
-            <a:off x="0" y="0"/>
+            <a:off x="-2" y="-1823"/>
             <a:ext cx="12188762" cy="6859823"/>
           </a:xfrm>
           <a:prstGeom prst="rect">
@@ -3426,8 +3437,8 @@
         </p:nvSpPr>
         <p:spPr>
           <a:xfrm>
-            <a:off x="2646101" y="4034613"/>
-            <a:ext cx="6896559" cy="2161755"/>
+            <a:off x="762216" y="4034613"/>
+            <a:ext cx="10664327" cy="2161755"/>
           </a:xfrm>
         </p:spPr>
         <p:txBody>
@@ -3441,7 +3452,7 @@
                 <a:latin typeface="Arial" panose="020B0604020202020204" pitchFamily="34" charset="0"/>
                 <a:cs typeface="Arial" panose="020B0604020202020204" pitchFamily="34" charset="0"/>
               </a:rPr>
-              <a:t>Presentation by:</a:t>
+              <a:t>Presented by:</a:t>
             </a:r>
             <a:r>
               <a:rPr lang="en-US" sz="2800" b="1" dirty="0">
@@ -3473,7 +3484,7 @@
                 <a:latin typeface="Arial" panose="020B0604020202020204" pitchFamily="34" charset="0"/>
                 <a:cs typeface="Arial" panose="020B0604020202020204" pitchFamily="34" charset="0"/>
               </a:rPr>
-              <a:t>AI110 – Foundations of AI Engineering</a:t>
+              <a:t>Course: AI110 – Foundations of AI Engineering</a:t>
             </a:r>
           </a:p>
           <a:p>
@@ -3491,6 +3502,4315 @@
     <p:extLst>
       <p:ext uri="{BB962C8B-B14F-4D97-AF65-F5344CB8AC3E}">
         <p14:creationId xmlns:p14="http://schemas.microsoft.com/office/powerpoint/2010/main" val="1831805"/>
+      </p:ext>
+    </p:extLst>
+  </p:cSld>
+  <p:clrMapOvr>
+    <a:masterClrMapping/>
+  </p:clrMapOvr>
+</p:sld>
+</file>
+
+<file path=ppt/slides/slide2.xml><?xml version="1.0" encoding="utf-8"?>
+<p:sld xmlns:a="http://schemas.openxmlformats.org/drawingml/2006/main" xmlns:r="http://schemas.openxmlformats.org/officeDocument/2006/relationships" xmlns:p="http://schemas.openxmlformats.org/presentationml/2006/main">
+  <p:cSld>
+    <p:spTree>
+      <p:nvGrpSpPr>
+        <p:cNvPr id="1" name=""/>
+        <p:cNvGrpSpPr/>
+        <p:nvPr/>
+      </p:nvGrpSpPr>
+      <p:grpSpPr>
+        <a:xfrm>
+          <a:off x="0" y="0"/>
+          <a:ext cx="0" cy="0"/>
+          <a:chOff x="0" y="0"/>
+          <a:chExt cx="0" cy="0"/>
+        </a:xfrm>
+      </p:grpSpPr>
+      <p:sp>
+        <p:nvSpPr>
+          <p:cNvPr id="2" name="Title 1">
+            <a:extLst>
+              <a:ext uri="{FF2B5EF4-FFF2-40B4-BE49-F238E27FC236}">
+                <a16:creationId xmlns:a16="http://schemas.microsoft.com/office/drawing/2014/main" id="{D9D6E2A0-134B-9013-96DE-1585F2B58740}"/>
+              </a:ext>
+            </a:extLst>
+          </p:cNvPr>
+          <p:cNvSpPr>
+            <a:spLocks noGrp="1"/>
+          </p:cNvSpPr>
+          <p:nvPr>
+            <p:ph type="title"/>
+          </p:nvPr>
+        </p:nvSpPr>
+        <p:spPr/>
+        <p:txBody>
+          <a:bodyPr/>
+          <a:lstStyle/>
+          <a:p>
+            <a:r>
+              <a:rPr lang="en-US" dirty="0"/>
+              <a:t>PawPal+ Scheduler</a:t>
+            </a:r>
+          </a:p>
+        </p:txBody>
+      </p:sp>
+      <p:sp>
+        <p:nvSpPr>
+          <p:cNvPr id="3" name="Content Placeholder 2">
+            <a:extLst>
+              <a:ext uri="{FF2B5EF4-FFF2-40B4-BE49-F238E27FC236}">
+                <a16:creationId xmlns:a16="http://schemas.microsoft.com/office/drawing/2014/main" id="{C437BF93-70B9-AD3B-97E1-495D38721734}"/>
+              </a:ext>
+            </a:extLst>
+          </p:cNvPr>
+          <p:cNvSpPr>
+            <a:spLocks noGrp="1"/>
+          </p:cNvSpPr>
+          <p:nvPr>
+            <p:ph idx="1"/>
+          </p:nvPr>
+        </p:nvSpPr>
+        <p:spPr>
+          <a:xfrm>
+            <a:off x="838200" y="1307832"/>
+            <a:ext cx="10515600" cy="487917"/>
+          </a:xfrm>
+        </p:spPr>
+        <p:txBody>
+          <a:bodyPr>
+            <a:normAutofit/>
+          </a:bodyPr>
+          <a:lstStyle/>
+          <a:p>
+            <a:pPr marL="0" indent="0">
+              <a:buNone/>
+            </a:pPr>
+            <a:r>
+              <a:rPr lang="en-US" sz="2400" dirty="0"/>
+              <a:t>The base project was a traditional pet-care task manager.</a:t>
+            </a:r>
+          </a:p>
+        </p:txBody>
+      </p:sp>
+      <p:sp>
+        <p:nvSpPr>
+          <p:cNvPr id="4" name="TextBox 3">
+            <a:extLst>
+              <a:ext uri="{FF2B5EF4-FFF2-40B4-BE49-F238E27FC236}">
+                <a16:creationId xmlns:a16="http://schemas.microsoft.com/office/drawing/2014/main" id="{5940874F-9F29-12D5-9928-885E0F35D195}"/>
+              </a:ext>
+            </a:extLst>
+          </p:cNvPr>
+          <p:cNvSpPr txBox="1"/>
+          <p:nvPr/>
+        </p:nvSpPr>
+        <p:spPr>
+          <a:xfrm>
+            <a:off x="838201" y="2016087"/>
+            <a:ext cx="4549048" cy="461665"/>
+          </a:xfrm>
+          <a:prstGeom prst="rect">
+            <a:avLst/>
+          </a:prstGeom>
+          <a:noFill/>
+        </p:spPr>
+        <p:txBody>
+          <a:bodyPr wrap="square" rtlCol="0">
+            <a:spAutoFit/>
+          </a:bodyPr>
+          <a:lstStyle/>
+          <a:p>
+            <a:r>
+              <a:rPr lang="en-US" sz="2400" b="1" dirty="0"/>
+              <a:t>Original scope</a:t>
+            </a:r>
+          </a:p>
+        </p:txBody>
+      </p:sp>
+      <p:sp>
+        <p:nvSpPr>
+          <p:cNvPr id="5" name="Rounded Rectangle 4">
+            <a:extLst>
+              <a:ext uri="{FF2B5EF4-FFF2-40B4-BE49-F238E27FC236}">
+                <a16:creationId xmlns:a16="http://schemas.microsoft.com/office/drawing/2014/main" id="{7B02FD5F-1DFF-4FBF-ED9E-E98336A85C95}"/>
+              </a:ext>
+            </a:extLst>
+          </p:cNvPr>
+          <p:cNvSpPr/>
+          <p:nvPr/>
+        </p:nvSpPr>
+        <p:spPr>
+          <a:xfrm>
+            <a:off x="838200" y="2477751"/>
+            <a:ext cx="4549048" cy="1164123"/>
+          </a:xfrm>
+          <a:prstGeom prst="roundRect">
+            <a:avLst/>
+          </a:prstGeom>
+          <a:noFill/>
+          <a:ln>
+            <a:solidFill>
+              <a:schemeClr val="bg1">
+                <a:lumMod val="65000"/>
+              </a:schemeClr>
+            </a:solidFill>
+          </a:ln>
+        </p:spPr>
+        <p:style>
+          <a:lnRef idx="2">
+            <a:schemeClr val="accent1">
+              <a:shade val="15000"/>
+            </a:schemeClr>
+          </a:lnRef>
+          <a:fillRef idx="1">
+            <a:schemeClr val="accent1"/>
+          </a:fillRef>
+          <a:effectRef idx="0">
+            <a:schemeClr val="accent1"/>
+          </a:effectRef>
+          <a:fontRef idx="minor">
+            <a:schemeClr val="lt1"/>
+          </a:fontRef>
+        </p:style>
+        <p:txBody>
+          <a:bodyPr rtlCol="0" anchor="ctr"/>
+          <a:lstStyle/>
+          <a:p>
+            <a:r>
+              <a:rPr lang="en-US" b="1" dirty="0">
+                <a:solidFill>
+                  <a:schemeClr val="tx1"/>
+                </a:solidFill>
+              </a:rPr>
+              <a:t>Multi-pet care schedule</a:t>
+            </a:r>
+          </a:p>
+          <a:p>
+            <a:r>
+              <a:rPr lang="en-US" dirty="0">
+                <a:solidFill>
+                  <a:schemeClr val="tx1"/>
+                </a:solidFill>
+              </a:rPr>
+              <a:t>Owner, Pet, Task, and Scheduler classes managed data and behavior.</a:t>
+            </a:r>
+          </a:p>
+        </p:txBody>
+      </p:sp>
+      <p:sp>
+        <p:nvSpPr>
+          <p:cNvPr id="8" name="Rounded Rectangle 7">
+            <a:extLst>
+              <a:ext uri="{FF2B5EF4-FFF2-40B4-BE49-F238E27FC236}">
+                <a16:creationId xmlns:a16="http://schemas.microsoft.com/office/drawing/2014/main" id="{12DA7D6D-47C4-2628-9F7C-5B61AE77BF25}"/>
+              </a:ext>
+            </a:extLst>
+          </p:cNvPr>
+          <p:cNvSpPr/>
+          <p:nvPr/>
+        </p:nvSpPr>
+        <p:spPr>
+          <a:xfrm>
+            <a:off x="838200" y="3774587"/>
+            <a:ext cx="4549048" cy="1164123"/>
+          </a:xfrm>
+          <a:prstGeom prst="roundRect">
+            <a:avLst/>
+          </a:prstGeom>
+          <a:noFill/>
+          <a:ln>
+            <a:solidFill>
+              <a:schemeClr val="bg1">
+                <a:lumMod val="65000"/>
+              </a:schemeClr>
+            </a:solidFill>
+          </a:ln>
+        </p:spPr>
+        <p:style>
+          <a:lnRef idx="2">
+            <a:schemeClr val="accent1">
+              <a:shade val="15000"/>
+            </a:schemeClr>
+          </a:lnRef>
+          <a:fillRef idx="1">
+            <a:schemeClr val="accent1"/>
+          </a:fillRef>
+          <a:effectRef idx="0">
+            <a:schemeClr val="accent1"/>
+          </a:effectRef>
+          <a:fontRef idx="minor">
+            <a:schemeClr val="lt1"/>
+          </a:fontRef>
+        </p:style>
+        <p:txBody>
+          <a:bodyPr rtlCol="0" anchor="ctr"/>
+          <a:lstStyle/>
+          <a:p>
+            <a:r>
+              <a:rPr lang="en-US" b="1" dirty="0">
+                <a:solidFill>
+                  <a:schemeClr val="tx1"/>
+                </a:solidFill>
+              </a:rPr>
+              <a:t>Smart scheduling basics</a:t>
+            </a:r>
+          </a:p>
+          <a:p>
+            <a:r>
+              <a:rPr lang="en-US" dirty="0">
+                <a:solidFill>
+                  <a:schemeClr val="tx1"/>
+                </a:solidFill>
+              </a:rPr>
+              <a:t>Sort by time/priority, filter by pet/status, detect conflicts, regenerate recurring tasks.</a:t>
+            </a:r>
+          </a:p>
+        </p:txBody>
+      </p:sp>
+      <p:sp>
+        <p:nvSpPr>
+          <p:cNvPr id="9" name="Rounded Rectangle 8">
+            <a:extLst>
+              <a:ext uri="{FF2B5EF4-FFF2-40B4-BE49-F238E27FC236}">
+                <a16:creationId xmlns:a16="http://schemas.microsoft.com/office/drawing/2014/main" id="{AC46B2D7-C348-B053-3334-60F80E0858D6}"/>
+              </a:ext>
+            </a:extLst>
+          </p:cNvPr>
+          <p:cNvSpPr/>
+          <p:nvPr/>
+        </p:nvSpPr>
+        <p:spPr>
+          <a:xfrm>
+            <a:off x="838200" y="5071423"/>
+            <a:ext cx="4549048" cy="1164123"/>
+          </a:xfrm>
+          <a:prstGeom prst="roundRect">
+            <a:avLst/>
+          </a:prstGeom>
+          <a:noFill/>
+          <a:ln>
+            <a:solidFill>
+              <a:schemeClr val="bg1">
+                <a:lumMod val="65000"/>
+              </a:schemeClr>
+            </a:solidFill>
+          </a:ln>
+        </p:spPr>
+        <p:style>
+          <a:lnRef idx="2">
+            <a:schemeClr val="accent1">
+              <a:shade val="15000"/>
+            </a:schemeClr>
+          </a:lnRef>
+          <a:fillRef idx="1">
+            <a:schemeClr val="accent1"/>
+          </a:fillRef>
+          <a:effectRef idx="0">
+            <a:schemeClr val="accent1"/>
+          </a:effectRef>
+          <a:fontRef idx="minor">
+            <a:schemeClr val="lt1"/>
+          </a:fontRef>
+        </p:style>
+        <p:txBody>
+          <a:bodyPr rtlCol="0" anchor="ctr"/>
+          <a:lstStyle/>
+          <a:p>
+            <a:r>
+              <a:rPr lang="en-US" b="1" dirty="0">
+                <a:solidFill>
+                  <a:schemeClr val="tx1"/>
+                </a:solidFill>
+              </a:rPr>
+              <a:t>Streamlit + CLI</a:t>
+            </a:r>
+          </a:p>
+          <a:p>
+            <a:r>
+              <a:rPr lang="en-US" dirty="0">
+                <a:solidFill>
+                  <a:schemeClr val="tx1"/>
+                </a:solidFill>
+              </a:rPr>
+              <a:t>Users could manage pets/tasks in the UI or run a command-line demo.</a:t>
+            </a:r>
+          </a:p>
+        </p:txBody>
+      </p:sp>
+      <p:sp>
+        <p:nvSpPr>
+          <p:cNvPr id="14" name="TextBox 13">
+            <a:extLst>
+              <a:ext uri="{FF2B5EF4-FFF2-40B4-BE49-F238E27FC236}">
+                <a16:creationId xmlns:a16="http://schemas.microsoft.com/office/drawing/2014/main" id="{38989337-BE02-2A17-9210-289271F62E0F}"/>
+              </a:ext>
+            </a:extLst>
+          </p:cNvPr>
+          <p:cNvSpPr txBox="1"/>
+          <p:nvPr/>
+        </p:nvSpPr>
+        <p:spPr>
+          <a:xfrm>
+            <a:off x="6804754" y="2016087"/>
+            <a:ext cx="4549048" cy="461665"/>
+          </a:xfrm>
+          <a:prstGeom prst="rect">
+            <a:avLst/>
+          </a:prstGeom>
+          <a:noFill/>
+        </p:spPr>
+        <p:txBody>
+          <a:bodyPr wrap="square" rtlCol="0">
+            <a:spAutoFit/>
+          </a:bodyPr>
+          <a:lstStyle/>
+          <a:p>
+            <a:r>
+              <a:rPr lang="en-US" sz="2400" b="1" dirty="0"/>
+              <a:t>Final-project extension goal</a:t>
+            </a:r>
+          </a:p>
+        </p:txBody>
+      </p:sp>
+      <p:sp>
+        <p:nvSpPr>
+          <p:cNvPr id="15" name="Rounded Rectangle 14">
+            <a:extLst>
+              <a:ext uri="{FF2B5EF4-FFF2-40B4-BE49-F238E27FC236}">
+                <a16:creationId xmlns:a16="http://schemas.microsoft.com/office/drawing/2014/main" id="{9D614AE6-ECCF-E246-7615-16B58A2EC736}"/>
+              </a:ext>
+            </a:extLst>
+          </p:cNvPr>
+          <p:cNvSpPr/>
+          <p:nvPr/>
+        </p:nvSpPr>
+        <p:spPr>
+          <a:xfrm>
+            <a:off x="6804753" y="2477752"/>
+            <a:ext cx="4549048" cy="1164122"/>
+          </a:xfrm>
+          <a:prstGeom prst="roundRect">
+            <a:avLst/>
+          </a:prstGeom>
+          <a:noFill/>
+          <a:ln>
+            <a:noFill/>
+          </a:ln>
+        </p:spPr>
+        <p:style>
+          <a:lnRef idx="2">
+            <a:schemeClr val="accent1">
+              <a:shade val="15000"/>
+            </a:schemeClr>
+          </a:lnRef>
+          <a:fillRef idx="1">
+            <a:schemeClr val="accent1"/>
+          </a:fillRef>
+          <a:effectRef idx="0">
+            <a:schemeClr val="accent1"/>
+          </a:effectRef>
+          <a:fontRef idx="minor">
+            <a:schemeClr val="lt1"/>
+          </a:fontRef>
+        </p:style>
+        <p:txBody>
+          <a:bodyPr rtlCol="0" anchor="ctr"/>
+          <a:lstStyle/>
+          <a:p>
+            <a:r>
+              <a:rPr lang="en-US" sz="2000" b="1" dirty="0">
+                <a:solidFill>
+                  <a:schemeClr val="tx1"/>
+                </a:solidFill>
+              </a:rPr>
+              <a:t>Move from “organize my tasks” to “understand my request, retrieve context, use tools, and respond safely.”</a:t>
+            </a:r>
+            <a:endParaRPr lang="en-US" sz="2000" dirty="0">
+              <a:solidFill>
+                <a:schemeClr val="tx1"/>
+              </a:solidFill>
+            </a:endParaRPr>
+          </a:p>
+        </p:txBody>
+      </p:sp>
+      <p:sp>
+        <p:nvSpPr>
+          <p:cNvPr id="16" name="Rounded Rectangle 15">
+            <a:extLst>
+              <a:ext uri="{FF2B5EF4-FFF2-40B4-BE49-F238E27FC236}">
+                <a16:creationId xmlns:a16="http://schemas.microsoft.com/office/drawing/2014/main" id="{34087B0C-15AB-2AAD-DEB3-AF72B4A80B9B}"/>
+              </a:ext>
+            </a:extLst>
+          </p:cNvPr>
+          <p:cNvSpPr/>
+          <p:nvPr/>
+        </p:nvSpPr>
+        <p:spPr>
+          <a:xfrm>
+            <a:off x="6804753" y="3774588"/>
+            <a:ext cx="4549048" cy="1164122"/>
+          </a:xfrm>
+          <a:prstGeom prst="roundRect">
+            <a:avLst/>
+          </a:prstGeom>
+          <a:solidFill>
+            <a:schemeClr val="accent2">
+              <a:lumMod val="40000"/>
+              <a:lumOff val="60000"/>
+            </a:schemeClr>
+          </a:solidFill>
+          <a:ln>
+            <a:solidFill>
+              <a:schemeClr val="accent2">
+                <a:lumMod val="40000"/>
+                <a:lumOff val="60000"/>
+              </a:schemeClr>
+            </a:solidFill>
+          </a:ln>
+        </p:spPr>
+        <p:style>
+          <a:lnRef idx="2">
+            <a:schemeClr val="accent1">
+              <a:shade val="15000"/>
+            </a:schemeClr>
+          </a:lnRef>
+          <a:fillRef idx="1">
+            <a:schemeClr val="accent1"/>
+          </a:fillRef>
+          <a:effectRef idx="0">
+            <a:schemeClr val="accent1"/>
+          </a:effectRef>
+          <a:fontRef idx="minor">
+            <a:schemeClr val="lt1"/>
+          </a:fontRef>
+        </p:style>
+        <p:txBody>
+          <a:bodyPr rtlCol="0" anchor="ctr"/>
+          <a:lstStyle/>
+          <a:p>
+            <a:r>
+              <a:rPr lang="en-US" b="1" dirty="0">
+                <a:solidFill>
+                  <a:schemeClr val="tx1"/>
+                </a:solidFill>
+              </a:rPr>
+              <a:t>Before</a:t>
+            </a:r>
+          </a:p>
+          <a:p>
+            <a:r>
+              <a:rPr lang="en-US" dirty="0">
+                <a:solidFill>
+                  <a:schemeClr val="tx1"/>
+                </a:solidFill>
+              </a:rPr>
+              <a:t>Manual scheduler with deterministic algorithms.</a:t>
+            </a:r>
+          </a:p>
+        </p:txBody>
+      </p:sp>
+      <p:sp>
+        <p:nvSpPr>
+          <p:cNvPr id="17" name="Rounded Rectangle 16">
+            <a:extLst>
+              <a:ext uri="{FF2B5EF4-FFF2-40B4-BE49-F238E27FC236}">
+                <a16:creationId xmlns:a16="http://schemas.microsoft.com/office/drawing/2014/main" id="{2CB7137F-3D67-B157-5EBE-4F17C1E1B869}"/>
+              </a:ext>
+            </a:extLst>
+          </p:cNvPr>
+          <p:cNvSpPr/>
+          <p:nvPr/>
+        </p:nvSpPr>
+        <p:spPr>
+          <a:xfrm>
+            <a:off x="6804753" y="5071424"/>
+            <a:ext cx="4549048" cy="1164122"/>
+          </a:xfrm>
+          <a:prstGeom prst="roundRect">
+            <a:avLst/>
+          </a:prstGeom>
+          <a:solidFill>
+            <a:schemeClr val="accent6">
+              <a:lumMod val="40000"/>
+              <a:lumOff val="60000"/>
+            </a:schemeClr>
+          </a:solidFill>
+          <a:ln>
+            <a:solidFill>
+              <a:schemeClr val="accent6">
+                <a:lumMod val="40000"/>
+                <a:lumOff val="60000"/>
+              </a:schemeClr>
+            </a:solidFill>
+          </a:ln>
+        </p:spPr>
+        <p:style>
+          <a:lnRef idx="2">
+            <a:schemeClr val="accent1">
+              <a:shade val="15000"/>
+            </a:schemeClr>
+          </a:lnRef>
+          <a:fillRef idx="1">
+            <a:schemeClr val="accent1"/>
+          </a:fillRef>
+          <a:effectRef idx="0">
+            <a:schemeClr val="accent1"/>
+          </a:effectRef>
+          <a:fontRef idx="minor">
+            <a:schemeClr val="lt1"/>
+          </a:fontRef>
+        </p:style>
+        <p:txBody>
+          <a:bodyPr rtlCol="0" anchor="ctr"/>
+          <a:lstStyle/>
+          <a:p>
+            <a:r>
+              <a:rPr lang="en-US" b="1" dirty="0">
+                <a:solidFill>
+                  <a:schemeClr val="tx1"/>
+                </a:solidFill>
+              </a:rPr>
+              <a:t>After</a:t>
+            </a:r>
+          </a:p>
+          <a:p>
+            <a:r>
+              <a:rPr lang="en-US" dirty="0">
+                <a:solidFill>
+                  <a:schemeClr val="tx1"/>
+                </a:solidFill>
+              </a:rPr>
+              <a:t>AI assistant with retrieval, agent actions, guardrails, and evaluation.</a:t>
+            </a:r>
+          </a:p>
+        </p:txBody>
+      </p:sp>
+      <p:sp>
+        <p:nvSpPr>
+          <p:cNvPr id="18" name="Right Arrow 17">
+            <a:extLst>
+              <a:ext uri="{FF2B5EF4-FFF2-40B4-BE49-F238E27FC236}">
+                <a16:creationId xmlns:a16="http://schemas.microsoft.com/office/drawing/2014/main" id="{D334042A-754F-1CE4-6887-380A9D92DDAD}"/>
+              </a:ext>
+            </a:extLst>
+          </p:cNvPr>
+          <p:cNvSpPr/>
+          <p:nvPr/>
+        </p:nvSpPr>
+        <p:spPr>
+          <a:xfrm>
+            <a:off x="5743461" y="4103260"/>
+            <a:ext cx="705079" cy="506776"/>
+          </a:xfrm>
+          <a:prstGeom prst="rightArrow">
+            <a:avLst>
+              <a:gd name="adj1" fmla="val 50000"/>
+              <a:gd name="adj2" fmla="val 76087"/>
+            </a:avLst>
+          </a:prstGeom>
+          <a:solidFill>
+            <a:schemeClr val="accent1">
+              <a:lumMod val="60000"/>
+              <a:lumOff val="40000"/>
+            </a:schemeClr>
+          </a:solidFill>
+          <a:ln>
+            <a:solidFill>
+              <a:schemeClr val="accent1">
+                <a:lumMod val="60000"/>
+                <a:lumOff val="40000"/>
+              </a:schemeClr>
+            </a:solidFill>
+          </a:ln>
+        </p:spPr>
+        <p:style>
+          <a:lnRef idx="2">
+            <a:schemeClr val="accent1">
+              <a:shade val="15000"/>
+            </a:schemeClr>
+          </a:lnRef>
+          <a:fillRef idx="1">
+            <a:schemeClr val="accent1"/>
+          </a:fillRef>
+          <a:effectRef idx="0">
+            <a:schemeClr val="accent1"/>
+          </a:effectRef>
+          <a:fontRef idx="minor">
+            <a:schemeClr val="lt1"/>
+          </a:fontRef>
+        </p:style>
+        <p:txBody>
+          <a:bodyPr rtlCol="0" anchor="ctr"/>
+          <a:lstStyle/>
+          <a:p>
+            <a:pPr algn="ctr"/>
+            <a:endParaRPr lang="en-US"/>
+          </a:p>
+        </p:txBody>
+      </p:sp>
+    </p:spTree>
+    <p:extLst>
+      <p:ext uri="{BB962C8B-B14F-4D97-AF65-F5344CB8AC3E}">
+        <p14:creationId xmlns:p14="http://schemas.microsoft.com/office/powerpoint/2010/main" val="3140492836"/>
+      </p:ext>
+    </p:extLst>
+  </p:cSld>
+  <p:clrMapOvr>
+    <a:masterClrMapping/>
+  </p:clrMapOvr>
+</p:sld>
+</file>
+
+<file path=ppt/slides/slide3.xml><?xml version="1.0" encoding="utf-8"?>
+<p:sld xmlns:a="http://schemas.openxmlformats.org/drawingml/2006/main" xmlns:r="http://schemas.openxmlformats.org/officeDocument/2006/relationships" xmlns:p="http://schemas.openxmlformats.org/presentationml/2006/main">
+  <p:cSld>
+    <p:spTree>
+      <p:nvGrpSpPr>
+        <p:cNvPr id="1" name=""/>
+        <p:cNvGrpSpPr/>
+        <p:nvPr/>
+      </p:nvGrpSpPr>
+      <p:grpSpPr>
+        <a:xfrm>
+          <a:off x="0" y="0"/>
+          <a:ext cx="0" cy="0"/>
+          <a:chOff x="0" y="0"/>
+          <a:chExt cx="0" cy="0"/>
+        </a:xfrm>
+      </p:grpSpPr>
+      <p:sp>
+        <p:nvSpPr>
+          <p:cNvPr id="2" name="Title 1">
+            <a:extLst>
+              <a:ext uri="{FF2B5EF4-FFF2-40B4-BE49-F238E27FC236}">
+                <a16:creationId xmlns:a16="http://schemas.microsoft.com/office/drawing/2014/main" id="{C9D99662-D087-6EF7-9777-47573857F1DF}"/>
+              </a:ext>
+            </a:extLst>
+          </p:cNvPr>
+          <p:cNvSpPr>
+            <a:spLocks noGrp="1"/>
+          </p:cNvSpPr>
+          <p:nvPr>
+            <p:ph type="title"/>
+          </p:nvPr>
+        </p:nvSpPr>
+        <p:spPr/>
+        <p:txBody>
+          <a:bodyPr/>
+          <a:lstStyle/>
+          <a:p>
+            <a:r>
+              <a:rPr lang="en-US" dirty="0"/>
+              <a:t>What I Added</a:t>
+            </a:r>
+          </a:p>
+        </p:txBody>
+      </p:sp>
+      <p:sp>
+        <p:nvSpPr>
+          <p:cNvPr id="4" name="TextBox 3">
+            <a:extLst>
+              <a:ext uri="{FF2B5EF4-FFF2-40B4-BE49-F238E27FC236}">
+                <a16:creationId xmlns:a16="http://schemas.microsoft.com/office/drawing/2014/main" id="{803BC180-0385-D2B6-6DBB-517771652922}"/>
+              </a:ext>
+            </a:extLst>
+          </p:cNvPr>
+          <p:cNvSpPr txBox="1"/>
+          <p:nvPr/>
+        </p:nvSpPr>
+        <p:spPr>
+          <a:xfrm>
+            <a:off x="838200" y="1432194"/>
+            <a:ext cx="10971881" cy="830997"/>
+          </a:xfrm>
+          <a:prstGeom prst="rect">
+            <a:avLst/>
+          </a:prstGeom>
+          <a:noFill/>
+        </p:spPr>
+        <p:txBody>
+          <a:bodyPr wrap="square" rtlCol="0">
+            <a:spAutoFit/>
+          </a:bodyPr>
+          <a:lstStyle/>
+          <a:p>
+            <a:r>
+              <a:rPr lang="en-US" sz="2400" b="1" dirty="0"/>
+              <a:t>The extension adds AI behavior that changes the working system, not just a standalone demo.</a:t>
+            </a:r>
+          </a:p>
+        </p:txBody>
+      </p:sp>
+      <p:sp>
+        <p:nvSpPr>
+          <p:cNvPr id="5" name="Rounded Rectangle 4">
+            <a:extLst>
+              <a:ext uri="{FF2B5EF4-FFF2-40B4-BE49-F238E27FC236}">
+                <a16:creationId xmlns:a16="http://schemas.microsoft.com/office/drawing/2014/main" id="{1ABA280C-D854-142A-AE02-21DE4B6E8447}"/>
+              </a:ext>
+            </a:extLst>
+          </p:cNvPr>
+          <p:cNvSpPr/>
+          <p:nvPr/>
+        </p:nvSpPr>
+        <p:spPr>
+          <a:xfrm>
+            <a:off x="177181" y="2397479"/>
+            <a:ext cx="3700749" cy="1557575"/>
+          </a:xfrm>
+          <a:prstGeom prst="roundRect">
+            <a:avLst/>
+          </a:prstGeom>
+          <a:solidFill>
+            <a:schemeClr val="accent5">
+              <a:lumMod val="20000"/>
+              <a:lumOff val="80000"/>
+            </a:schemeClr>
+          </a:solidFill>
+          <a:ln>
+            <a:solidFill>
+              <a:schemeClr val="accent5">
+                <a:lumMod val="20000"/>
+                <a:lumOff val="80000"/>
+              </a:schemeClr>
+            </a:solidFill>
+          </a:ln>
+        </p:spPr>
+        <p:style>
+          <a:lnRef idx="2">
+            <a:schemeClr val="accent1">
+              <a:shade val="15000"/>
+            </a:schemeClr>
+          </a:lnRef>
+          <a:fillRef idx="1">
+            <a:schemeClr val="accent1"/>
+          </a:fillRef>
+          <a:effectRef idx="0">
+            <a:schemeClr val="accent1"/>
+          </a:effectRef>
+          <a:fontRef idx="minor">
+            <a:schemeClr val="lt1"/>
+          </a:fontRef>
+        </p:style>
+        <p:txBody>
+          <a:bodyPr rtlCol="0" anchor="ctr"/>
+          <a:lstStyle/>
+          <a:p>
+            <a:r>
+              <a:rPr lang="en-US" b="1" dirty="0">
+                <a:solidFill>
+                  <a:schemeClr val="tx1"/>
+                </a:solidFill>
+              </a:rPr>
+              <a:t>RAG retrieval</a:t>
+            </a:r>
+          </a:p>
+          <a:p>
+            <a:r>
+              <a:rPr lang="en-US" dirty="0">
+                <a:solidFill>
+                  <a:schemeClr val="tx1"/>
+                </a:solidFill>
+              </a:rPr>
+              <a:t>TF-IDF local retrieval and optional Gemini embeddings search over curated pet-care knowledge + live scheduling context.</a:t>
+            </a:r>
+          </a:p>
+        </p:txBody>
+      </p:sp>
+      <p:sp>
+        <p:nvSpPr>
+          <p:cNvPr id="6" name="Rounded Rectangle 5">
+            <a:extLst>
+              <a:ext uri="{FF2B5EF4-FFF2-40B4-BE49-F238E27FC236}">
+                <a16:creationId xmlns:a16="http://schemas.microsoft.com/office/drawing/2014/main" id="{C77DA792-6CD0-5F6F-192D-5EBAF530CF3A}"/>
+              </a:ext>
+            </a:extLst>
+          </p:cNvPr>
+          <p:cNvSpPr/>
+          <p:nvPr/>
+        </p:nvSpPr>
+        <p:spPr>
+          <a:xfrm>
+            <a:off x="4268111" y="2397478"/>
+            <a:ext cx="3700749" cy="1557575"/>
+          </a:xfrm>
+          <a:prstGeom prst="roundRect">
+            <a:avLst/>
+          </a:prstGeom>
+          <a:solidFill>
+            <a:schemeClr val="accent4">
+              <a:lumMod val="20000"/>
+              <a:lumOff val="80000"/>
+            </a:schemeClr>
+          </a:solidFill>
+          <a:ln>
+            <a:solidFill>
+              <a:schemeClr val="accent4">
+                <a:lumMod val="20000"/>
+                <a:lumOff val="80000"/>
+              </a:schemeClr>
+            </a:solidFill>
+          </a:ln>
+        </p:spPr>
+        <p:style>
+          <a:lnRef idx="2">
+            <a:schemeClr val="accent1">
+              <a:shade val="15000"/>
+            </a:schemeClr>
+          </a:lnRef>
+          <a:fillRef idx="1">
+            <a:schemeClr val="accent1"/>
+          </a:fillRef>
+          <a:effectRef idx="0">
+            <a:schemeClr val="accent1"/>
+          </a:effectRef>
+          <a:fontRef idx="minor">
+            <a:schemeClr val="lt1"/>
+          </a:fontRef>
+        </p:style>
+        <p:txBody>
+          <a:bodyPr rtlCol="0" anchor="ctr"/>
+          <a:lstStyle/>
+          <a:p>
+            <a:r>
+              <a:rPr lang="en-US" b="1" dirty="0">
+                <a:solidFill>
+                  <a:schemeClr val="tx1"/>
+                </a:solidFill>
+              </a:rPr>
+              <a:t>Agentic workflow</a:t>
+            </a:r>
+          </a:p>
+          <a:p>
+            <a:r>
+              <a:rPr lang="en-US" dirty="0">
+                <a:solidFill>
+                  <a:schemeClr val="tx1"/>
+                </a:solidFill>
+              </a:rPr>
+              <a:t>A </a:t>
+            </a:r>
+            <a:r>
+              <a:rPr lang="en-US" dirty="0" err="1">
+                <a:solidFill>
+                  <a:schemeClr val="tx1"/>
+                </a:solidFill>
+              </a:rPr>
+              <a:t>ReAct</a:t>
+            </a:r>
+            <a:r>
+              <a:rPr lang="en-US" dirty="0">
+                <a:solidFill>
+                  <a:schemeClr val="tx1"/>
+                </a:solidFill>
+              </a:rPr>
+              <a:t>-style agent shows observable thought/action steps and can call scheduler tools.</a:t>
+            </a:r>
+          </a:p>
+        </p:txBody>
+      </p:sp>
+      <p:sp>
+        <p:nvSpPr>
+          <p:cNvPr id="7" name="Rounded Rectangle 6">
+            <a:extLst>
+              <a:ext uri="{FF2B5EF4-FFF2-40B4-BE49-F238E27FC236}">
+                <a16:creationId xmlns:a16="http://schemas.microsoft.com/office/drawing/2014/main" id="{B494196D-9065-90C6-3037-8A5D30578777}"/>
+              </a:ext>
+            </a:extLst>
+          </p:cNvPr>
+          <p:cNvSpPr/>
+          <p:nvPr/>
+        </p:nvSpPr>
+        <p:spPr>
+          <a:xfrm>
+            <a:off x="8359041" y="2397478"/>
+            <a:ext cx="3700749" cy="1557575"/>
+          </a:xfrm>
+          <a:prstGeom prst="roundRect">
+            <a:avLst/>
+          </a:prstGeom>
+          <a:solidFill>
+            <a:schemeClr val="accent6">
+              <a:lumMod val="20000"/>
+              <a:lumOff val="80000"/>
+            </a:schemeClr>
+          </a:solidFill>
+          <a:ln>
+            <a:solidFill>
+              <a:schemeClr val="accent6">
+                <a:lumMod val="20000"/>
+                <a:lumOff val="80000"/>
+              </a:schemeClr>
+            </a:solidFill>
+          </a:ln>
+        </p:spPr>
+        <p:style>
+          <a:lnRef idx="2">
+            <a:schemeClr val="accent1">
+              <a:shade val="15000"/>
+            </a:schemeClr>
+          </a:lnRef>
+          <a:fillRef idx="1">
+            <a:schemeClr val="accent1"/>
+          </a:fillRef>
+          <a:effectRef idx="0">
+            <a:schemeClr val="accent1"/>
+          </a:effectRef>
+          <a:fontRef idx="minor">
+            <a:schemeClr val="lt1"/>
+          </a:fontRef>
+        </p:style>
+        <p:txBody>
+          <a:bodyPr rtlCol="0" anchor="ctr"/>
+          <a:lstStyle/>
+          <a:p>
+            <a:r>
+              <a:rPr lang="en-US" b="1" dirty="0">
+                <a:solidFill>
+                  <a:schemeClr val="tx1"/>
+                </a:solidFill>
+              </a:rPr>
+              <a:t>Flexible models</a:t>
+            </a:r>
+          </a:p>
+          <a:p>
+            <a:r>
+              <a:rPr lang="en-US" dirty="0">
+                <a:solidFill>
+                  <a:schemeClr val="tx1"/>
+                </a:solidFill>
+              </a:rPr>
+              <a:t>Users can choose deterministic local behavior, Gemini, or Ollama local models.</a:t>
+            </a:r>
+          </a:p>
+        </p:txBody>
+      </p:sp>
+      <p:sp>
+        <p:nvSpPr>
+          <p:cNvPr id="8" name="Rounded Rectangle 7">
+            <a:extLst>
+              <a:ext uri="{FF2B5EF4-FFF2-40B4-BE49-F238E27FC236}">
+                <a16:creationId xmlns:a16="http://schemas.microsoft.com/office/drawing/2014/main" id="{1F538945-70D2-5404-2043-0419E8AB570F}"/>
+              </a:ext>
+            </a:extLst>
+          </p:cNvPr>
+          <p:cNvSpPr/>
+          <p:nvPr/>
+        </p:nvSpPr>
+        <p:spPr>
+          <a:xfrm>
+            <a:off x="2027555" y="4477830"/>
+            <a:ext cx="3700749" cy="1557575"/>
+          </a:xfrm>
+          <a:prstGeom prst="roundRect">
+            <a:avLst/>
+          </a:prstGeom>
+          <a:solidFill>
+            <a:srgbClr val="EEB5AE"/>
+          </a:solidFill>
+          <a:ln>
+            <a:solidFill>
+              <a:srgbClr val="EEB5AE"/>
+            </a:solidFill>
+          </a:ln>
+        </p:spPr>
+        <p:style>
+          <a:lnRef idx="2">
+            <a:schemeClr val="accent1">
+              <a:shade val="15000"/>
+            </a:schemeClr>
+          </a:lnRef>
+          <a:fillRef idx="1">
+            <a:schemeClr val="accent1"/>
+          </a:fillRef>
+          <a:effectRef idx="0">
+            <a:schemeClr val="accent1"/>
+          </a:effectRef>
+          <a:fontRef idx="minor">
+            <a:schemeClr val="lt1"/>
+          </a:fontRef>
+        </p:style>
+        <p:txBody>
+          <a:bodyPr rtlCol="0" anchor="ctr"/>
+          <a:lstStyle/>
+          <a:p>
+            <a:r>
+              <a:rPr lang="en-US" b="1" dirty="0">
+                <a:solidFill>
+                  <a:schemeClr val="tx1"/>
+                </a:solidFill>
+              </a:rPr>
+              <a:t>Guardrails</a:t>
+            </a:r>
+          </a:p>
+          <a:p>
+            <a:r>
+              <a:rPr lang="en-US" dirty="0">
+                <a:solidFill>
+                  <a:schemeClr val="tx1"/>
+                </a:solidFill>
+              </a:rPr>
+              <a:t>Prompt-injection detection, emergency medical redirect, validation, structured output, and scoring.</a:t>
+            </a:r>
+          </a:p>
+        </p:txBody>
+      </p:sp>
+      <p:sp>
+        <p:nvSpPr>
+          <p:cNvPr id="9" name="Rounded Rectangle 8">
+            <a:extLst>
+              <a:ext uri="{FF2B5EF4-FFF2-40B4-BE49-F238E27FC236}">
+                <a16:creationId xmlns:a16="http://schemas.microsoft.com/office/drawing/2014/main" id="{660ED811-055E-2FCC-0826-4885273A668D}"/>
+              </a:ext>
+            </a:extLst>
+          </p:cNvPr>
+          <p:cNvSpPr/>
+          <p:nvPr/>
+        </p:nvSpPr>
+        <p:spPr>
+          <a:xfrm>
+            <a:off x="6508666" y="4477829"/>
+            <a:ext cx="3700749" cy="1557575"/>
+          </a:xfrm>
+          <a:prstGeom prst="roundRect">
+            <a:avLst/>
+          </a:prstGeom>
+          <a:solidFill>
+            <a:schemeClr val="accent2">
+              <a:lumMod val="20000"/>
+              <a:lumOff val="80000"/>
+            </a:schemeClr>
+          </a:solidFill>
+          <a:ln>
+            <a:solidFill>
+              <a:schemeClr val="accent2">
+                <a:lumMod val="20000"/>
+                <a:lumOff val="80000"/>
+              </a:schemeClr>
+            </a:solidFill>
+          </a:ln>
+        </p:spPr>
+        <p:style>
+          <a:lnRef idx="2">
+            <a:schemeClr val="accent1">
+              <a:shade val="15000"/>
+            </a:schemeClr>
+          </a:lnRef>
+          <a:fillRef idx="1">
+            <a:schemeClr val="accent1"/>
+          </a:fillRef>
+          <a:effectRef idx="0">
+            <a:schemeClr val="accent1"/>
+          </a:effectRef>
+          <a:fontRef idx="minor">
+            <a:schemeClr val="lt1"/>
+          </a:fontRef>
+        </p:style>
+        <p:txBody>
+          <a:bodyPr rtlCol="0" anchor="ctr"/>
+          <a:lstStyle/>
+          <a:p>
+            <a:r>
+              <a:rPr lang="en-US" b="1" dirty="0">
+                <a:solidFill>
+                  <a:schemeClr val="tx1"/>
+                </a:solidFill>
+              </a:rPr>
+              <a:t>Evaluation harness</a:t>
+            </a:r>
+          </a:p>
+          <a:p>
+            <a:r>
+              <a:rPr lang="en-US" dirty="0">
+                <a:solidFill>
+                  <a:schemeClr val="tx1"/>
+                </a:solidFill>
+              </a:rPr>
+              <a:t>Automated tests including 10+ scenario evaluation with pass/fail and confidence summary</a:t>
+            </a:r>
+          </a:p>
+        </p:txBody>
+      </p:sp>
+    </p:spTree>
+    <p:extLst>
+      <p:ext uri="{BB962C8B-B14F-4D97-AF65-F5344CB8AC3E}">
+        <p14:creationId xmlns:p14="http://schemas.microsoft.com/office/powerpoint/2010/main" val="2491461998"/>
+      </p:ext>
+    </p:extLst>
+  </p:cSld>
+  <p:clrMapOvr>
+    <a:masterClrMapping/>
+  </p:clrMapOvr>
+</p:sld>
+</file>
+
+<file path=ppt/slides/slide4.xml><?xml version="1.0" encoding="utf-8"?>
+<p:sld xmlns:a="http://schemas.openxmlformats.org/drawingml/2006/main" xmlns:r="http://schemas.openxmlformats.org/officeDocument/2006/relationships" xmlns:p="http://schemas.openxmlformats.org/presentationml/2006/main">
+  <p:cSld>
+    <p:spTree>
+      <p:nvGrpSpPr>
+        <p:cNvPr id="1" name=""/>
+        <p:cNvGrpSpPr/>
+        <p:nvPr/>
+      </p:nvGrpSpPr>
+      <p:grpSpPr>
+        <a:xfrm>
+          <a:off x="0" y="0"/>
+          <a:ext cx="0" cy="0"/>
+          <a:chOff x="0" y="0"/>
+          <a:chExt cx="0" cy="0"/>
+        </a:xfrm>
+      </p:grpSpPr>
+      <p:sp>
+        <p:nvSpPr>
+          <p:cNvPr id="2" name="Title 1">
+            <a:extLst>
+              <a:ext uri="{FF2B5EF4-FFF2-40B4-BE49-F238E27FC236}">
+                <a16:creationId xmlns:a16="http://schemas.microsoft.com/office/drawing/2014/main" id="{52F79CF0-64F8-84FF-C800-5917A9817F9C}"/>
+              </a:ext>
+            </a:extLst>
+          </p:cNvPr>
+          <p:cNvSpPr>
+            <a:spLocks noGrp="1"/>
+          </p:cNvSpPr>
+          <p:nvPr>
+            <p:ph type="title"/>
+          </p:nvPr>
+        </p:nvSpPr>
+        <p:spPr>
+          <a:xfrm>
+            <a:off x="838200" y="127131"/>
+            <a:ext cx="10515600" cy="824697"/>
+          </a:xfrm>
+        </p:spPr>
+        <p:txBody>
+          <a:bodyPr/>
+          <a:lstStyle/>
+          <a:p>
+            <a:r>
+              <a:rPr lang="en-US" dirty="0"/>
+              <a:t>System Architecture</a:t>
+            </a:r>
+          </a:p>
+        </p:txBody>
+      </p:sp>
+      <p:sp>
+        <p:nvSpPr>
+          <p:cNvPr id="4" name="TextBox 3">
+            <a:extLst>
+              <a:ext uri="{FF2B5EF4-FFF2-40B4-BE49-F238E27FC236}">
+                <a16:creationId xmlns:a16="http://schemas.microsoft.com/office/drawing/2014/main" id="{E7644077-6ABB-ECE4-5B0C-7519FE7EA7A6}"/>
+              </a:ext>
+            </a:extLst>
+          </p:cNvPr>
+          <p:cNvSpPr txBox="1"/>
+          <p:nvPr/>
+        </p:nvSpPr>
+        <p:spPr>
+          <a:xfrm>
+            <a:off x="838199" y="843666"/>
+            <a:ext cx="10971881" cy="461665"/>
+          </a:xfrm>
+          <a:prstGeom prst="rect">
+            <a:avLst/>
+          </a:prstGeom>
+          <a:noFill/>
+        </p:spPr>
+        <p:txBody>
+          <a:bodyPr wrap="square" rtlCol="0">
+            <a:spAutoFit/>
+          </a:bodyPr>
+          <a:lstStyle/>
+          <a:p>
+            <a:r>
+              <a:rPr lang="en-US" sz="2400" b="1" dirty="0"/>
+              <a:t>Data flow: </a:t>
+            </a:r>
+            <a:r>
+              <a:rPr lang="en-US" sz="2400" dirty="0"/>
+              <a:t>Input </a:t>
+            </a:r>
+            <a:r>
+              <a:rPr lang="en-US" sz="2400" dirty="0">
+                <a:sym typeface="Wingdings" pitchFamily="2" charset="2"/>
+              </a:rPr>
+              <a:t> guardrails  retrieval/model/tools  structured output</a:t>
+            </a:r>
+            <a:endParaRPr lang="en-US" sz="2400" b="1" dirty="0"/>
+          </a:p>
+        </p:txBody>
+      </p:sp>
+      <p:sp>
+        <p:nvSpPr>
+          <p:cNvPr id="6" name="Rounded Rectangle 5">
+            <a:extLst>
+              <a:ext uri="{FF2B5EF4-FFF2-40B4-BE49-F238E27FC236}">
+                <a16:creationId xmlns:a16="http://schemas.microsoft.com/office/drawing/2014/main" id="{51F303B1-EDD9-E3F9-0815-42C0C6391F4B}"/>
+              </a:ext>
+            </a:extLst>
+          </p:cNvPr>
+          <p:cNvSpPr/>
+          <p:nvPr/>
+        </p:nvSpPr>
+        <p:spPr>
+          <a:xfrm>
+            <a:off x="79017" y="3738051"/>
+            <a:ext cx="1443210" cy="627961"/>
+          </a:xfrm>
+          <a:prstGeom prst="roundRect">
+            <a:avLst/>
+          </a:prstGeom>
+          <a:solidFill>
+            <a:schemeClr val="accent1">
+              <a:lumMod val="20000"/>
+              <a:lumOff val="80000"/>
+            </a:schemeClr>
+          </a:solidFill>
+          <a:ln>
+            <a:solidFill>
+              <a:schemeClr val="accent1">
+                <a:lumMod val="20000"/>
+                <a:lumOff val="80000"/>
+              </a:schemeClr>
+            </a:solidFill>
+          </a:ln>
+        </p:spPr>
+        <p:style>
+          <a:lnRef idx="2">
+            <a:schemeClr val="accent1">
+              <a:shade val="15000"/>
+            </a:schemeClr>
+          </a:lnRef>
+          <a:fillRef idx="1">
+            <a:schemeClr val="accent1"/>
+          </a:fillRef>
+          <a:effectRef idx="0">
+            <a:schemeClr val="accent1"/>
+          </a:effectRef>
+          <a:fontRef idx="minor">
+            <a:schemeClr val="lt1"/>
+          </a:fontRef>
+        </p:style>
+        <p:txBody>
+          <a:bodyPr rtlCol="0" anchor="ctr"/>
+          <a:lstStyle/>
+          <a:p>
+            <a:pPr algn="ctr"/>
+            <a:r>
+              <a:rPr lang="en-US" dirty="0">
+                <a:solidFill>
+                  <a:schemeClr val="tx1"/>
+                </a:solidFill>
+              </a:rPr>
+              <a:t>Streamlit UI + CLI</a:t>
+            </a:r>
+          </a:p>
+        </p:txBody>
+      </p:sp>
+      <p:sp>
+        <p:nvSpPr>
+          <p:cNvPr id="7" name="Rounded Rectangle 6">
+            <a:extLst>
+              <a:ext uri="{FF2B5EF4-FFF2-40B4-BE49-F238E27FC236}">
+                <a16:creationId xmlns:a16="http://schemas.microsoft.com/office/drawing/2014/main" id="{72A319CD-7F49-5752-B138-F8105266D83F}"/>
+              </a:ext>
+            </a:extLst>
+          </p:cNvPr>
+          <p:cNvSpPr/>
+          <p:nvPr/>
+        </p:nvSpPr>
+        <p:spPr>
+          <a:xfrm>
+            <a:off x="1213263" y="2556278"/>
+            <a:ext cx="2231834" cy="861026"/>
+          </a:xfrm>
+          <a:prstGeom prst="roundRect">
+            <a:avLst/>
+          </a:prstGeom>
+          <a:solidFill>
+            <a:schemeClr val="accent2">
+              <a:lumMod val="20000"/>
+              <a:lumOff val="80000"/>
+            </a:schemeClr>
+          </a:solidFill>
+          <a:ln>
+            <a:solidFill>
+              <a:schemeClr val="accent2">
+                <a:lumMod val="20000"/>
+                <a:lumOff val="80000"/>
+              </a:schemeClr>
+            </a:solidFill>
+          </a:ln>
+        </p:spPr>
+        <p:style>
+          <a:lnRef idx="2">
+            <a:schemeClr val="accent1">
+              <a:shade val="15000"/>
+            </a:schemeClr>
+          </a:lnRef>
+          <a:fillRef idx="1">
+            <a:schemeClr val="accent1"/>
+          </a:fillRef>
+          <a:effectRef idx="0">
+            <a:schemeClr val="accent1"/>
+          </a:effectRef>
+          <a:fontRef idx="minor">
+            <a:schemeClr val="lt1"/>
+          </a:fontRef>
+        </p:style>
+        <p:txBody>
+          <a:bodyPr rtlCol="0" anchor="ctr"/>
+          <a:lstStyle/>
+          <a:p>
+            <a:pPr algn="ctr"/>
+            <a:r>
+              <a:rPr lang="en-US" dirty="0">
+                <a:solidFill>
+                  <a:schemeClr val="tx1"/>
+                </a:solidFill>
+              </a:rPr>
+              <a:t>Guardrails validation, injection medical redirect</a:t>
+            </a:r>
+          </a:p>
+        </p:txBody>
+      </p:sp>
+      <p:cxnSp>
+        <p:nvCxnSpPr>
+          <p:cNvPr id="9" name="Elbow Connector 8">
+            <a:extLst>
+              <a:ext uri="{FF2B5EF4-FFF2-40B4-BE49-F238E27FC236}">
+                <a16:creationId xmlns:a16="http://schemas.microsoft.com/office/drawing/2014/main" id="{41638131-264C-BB08-AE10-82420D7381A8}"/>
+              </a:ext>
+            </a:extLst>
+          </p:cNvPr>
+          <p:cNvCxnSpPr>
+            <a:stCxn id="6" idx="0"/>
+            <a:endCxn id="7" idx="1"/>
+          </p:cNvCxnSpPr>
+          <p:nvPr/>
+        </p:nvCxnSpPr>
+        <p:spPr>
+          <a:xfrm rot="5400000" flipH="1" flipV="1">
+            <a:off x="631312" y="3156101"/>
+            <a:ext cx="751260" cy="412641"/>
+          </a:xfrm>
+          <a:prstGeom prst="bentConnector2">
+            <a:avLst/>
+          </a:prstGeom>
+          <a:ln>
+            <a:solidFill>
+              <a:schemeClr val="tx1"/>
+            </a:solidFill>
+            <a:tailEnd type="stealth" w="lg" len="lg"/>
+          </a:ln>
+        </p:spPr>
+        <p:style>
+          <a:lnRef idx="2">
+            <a:schemeClr val="accent1"/>
+          </a:lnRef>
+          <a:fillRef idx="0">
+            <a:schemeClr val="accent1"/>
+          </a:fillRef>
+          <a:effectRef idx="1">
+            <a:schemeClr val="accent1"/>
+          </a:effectRef>
+          <a:fontRef idx="minor">
+            <a:schemeClr val="tx1"/>
+          </a:fontRef>
+        </p:style>
+      </p:cxnSp>
+      <p:sp>
+        <p:nvSpPr>
+          <p:cNvPr id="10" name="Rounded Rectangle 9">
+            <a:extLst>
+              <a:ext uri="{FF2B5EF4-FFF2-40B4-BE49-F238E27FC236}">
+                <a16:creationId xmlns:a16="http://schemas.microsoft.com/office/drawing/2014/main" id="{26132706-B5CB-D7FB-4935-32642C4EC38B}"/>
+              </a:ext>
+            </a:extLst>
+          </p:cNvPr>
+          <p:cNvSpPr/>
+          <p:nvPr/>
+        </p:nvSpPr>
+        <p:spPr>
+          <a:xfrm>
+            <a:off x="3536246" y="3615882"/>
+            <a:ext cx="1746394" cy="861026"/>
+          </a:xfrm>
+          <a:prstGeom prst="roundRect">
+            <a:avLst/>
+          </a:prstGeom>
+          <a:solidFill>
+            <a:schemeClr val="accent6">
+              <a:lumMod val="20000"/>
+              <a:lumOff val="80000"/>
+            </a:schemeClr>
+          </a:solidFill>
+          <a:ln>
+            <a:solidFill>
+              <a:schemeClr val="accent6">
+                <a:lumMod val="20000"/>
+                <a:lumOff val="80000"/>
+              </a:schemeClr>
+            </a:solidFill>
+          </a:ln>
+        </p:spPr>
+        <p:style>
+          <a:lnRef idx="2">
+            <a:schemeClr val="accent1">
+              <a:shade val="15000"/>
+            </a:schemeClr>
+          </a:lnRef>
+          <a:fillRef idx="1">
+            <a:schemeClr val="accent1"/>
+          </a:fillRef>
+          <a:effectRef idx="0">
+            <a:schemeClr val="accent1"/>
+          </a:effectRef>
+          <a:fontRef idx="minor">
+            <a:schemeClr val="lt1"/>
+          </a:fontRef>
+        </p:style>
+        <p:txBody>
+          <a:bodyPr rtlCol="0" anchor="ctr"/>
+          <a:lstStyle/>
+          <a:p>
+            <a:pPr algn="ctr"/>
+            <a:r>
+              <a:rPr lang="en-US" dirty="0">
+                <a:solidFill>
+                  <a:schemeClr val="tx1"/>
+                </a:solidFill>
+              </a:rPr>
+              <a:t>ReAct Agent trace, critique confidence</a:t>
+            </a:r>
+          </a:p>
+        </p:txBody>
+      </p:sp>
+      <p:cxnSp>
+        <p:nvCxnSpPr>
+          <p:cNvPr id="12" name="Elbow Connector 11">
+            <a:extLst>
+              <a:ext uri="{FF2B5EF4-FFF2-40B4-BE49-F238E27FC236}">
+                <a16:creationId xmlns:a16="http://schemas.microsoft.com/office/drawing/2014/main" id="{7A2BD7DF-53B1-AD61-B450-3243AB6AD676}"/>
+              </a:ext>
+            </a:extLst>
+          </p:cNvPr>
+          <p:cNvCxnSpPr>
+            <a:cxnSpLocks/>
+            <a:stCxn id="7" idx="3"/>
+            <a:endCxn id="10" idx="0"/>
+          </p:cNvCxnSpPr>
+          <p:nvPr/>
+        </p:nvCxnSpPr>
+        <p:spPr>
+          <a:xfrm>
+            <a:off x="3445097" y="2986791"/>
+            <a:ext cx="964346" cy="629091"/>
+          </a:xfrm>
+          <a:prstGeom prst="bentConnector2">
+            <a:avLst/>
+          </a:prstGeom>
+          <a:ln>
+            <a:solidFill>
+              <a:schemeClr val="tx1"/>
+            </a:solidFill>
+            <a:tailEnd type="stealth" w="lg" len="lg"/>
+          </a:ln>
+        </p:spPr>
+        <p:style>
+          <a:lnRef idx="2">
+            <a:schemeClr val="accent1"/>
+          </a:lnRef>
+          <a:fillRef idx="0">
+            <a:schemeClr val="accent1"/>
+          </a:fillRef>
+          <a:effectRef idx="1">
+            <a:schemeClr val="accent1"/>
+          </a:effectRef>
+          <a:fontRef idx="minor">
+            <a:schemeClr val="tx1"/>
+          </a:fontRef>
+        </p:style>
+      </p:cxnSp>
+      <p:cxnSp>
+        <p:nvCxnSpPr>
+          <p:cNvPr id="14" name="Straight Arrow Connector 13">
+            <a:extLst>
+              <a:ext uri="{FF2B5EF4-FFF2-40B4-BE49-F238E27FC236}">
+                <a16:creationId xmlns:a16="http://schemas.microsoft.com/office/drawing/2014/main" id="{6989EABE-C909-8928-79F8-4D63DDC6D6A9}"/>
+              </a:ext>
+            </a:extLst>
+          </p:cNvPr>
+          <p:cNvCxnSpPr>
+            <a:stCxn id="10" idx="1"/>
+            <a:endCxn id="6" idx="3"/>
+          </p:cNvCxnSpPr>
+          <p:nvPr/>
+        </p:nvCxnSpPr>
+        <p:spPr>
+          <a:xfrm flipH="1">
+            <a:off x="1522227" y="4046395"/>
+            <a:ext cx="2014019" cy="5637"/>
+          </a:xfrm>
+          <a:prstGeom prst="straightConnector1">
+            <a:avLst/>
+          </a:prstGeom>
+          <a:ln>
+            <a:solidFill>
+              <a:schemeClr val="tx1"/>
+            </a:solidFill>
+            <a:tailEnd type="stealth" w="lg" len="lg"/>
+          </a:ln>
+        </p:spPr>
+        <p:style>
+          <a:lnRef idx="2">
+            <a:schemeClr val="accent1"/>
+          </a:lnRef>
+          <a:fillRef idx="0">
+            <a:schemeClr val="accent1"/>
+          </a:fillRef>
+          <a:effectRef idx="1">
+            <a:schemeClr val="accent1"/>
+          </a:effectRef>
+          <a:fontRef idx="minor">
+            <a:schemeClr val="tx1"/>
+          </a:fontRef>
+        </p:style>
+      </p:cxnSp>
+      <p:sp>
+        <p:nvSpPr>
+          <p:cNvPr id="15" name="Rounded Rectangle 14">
+            <a:extLst>
+              <a:ext uri="{FF2B5EF4-FFF2-40B4-BE49-F238E27FC236}">
+                <a16:creationId xmlns:a16="http://schemas.microsoft.com/office/drawing/2014/main" id="{939582AC-43FB-215C-D8F1-E86B5DB75044}"/>
+              </a:ext>
+            </a:extLst>
+          </p:cNvPr>
+          <p:cNvSpPr/>
+          <p:nvPr/>
+        </p:nvSpPr>
+        <p:spPr>
+          <a:xfrm>
+            <a:off x="578402" y="5448831"/>
+            <a:ext cx="2274183" cy="806050"/>
+          </a:xfrm>
+          <a:prstGeom prst="roundRect">
+            <a:avLst/>
+          </a:prstGeom>
+          <a:solidFill>
+            <a:schemeClr val="accent1">
+              <a:lumMod val="20000"/>
+              <a:lumOff val="80000"/>
+            </a:schemeClr>
+          </a:solidFill>
+          <a:ln>
+            <a:solidFill>
+              <a:schemeClr val="accent1">
+                <a:lumMod val="20000"/>
+                <a:lumOff val="80000"/>
+              </a:schemeClr>
+            </a:solidFill>
+          </a:ln>
+        </p:spPr>
+        <p:style>
+          <a:lnRef idx="2">
+            <a:schemeClr val="accent1">
+              <a:shade val="15000"/>
+            </a:schemeClr>
+          </a:lnRef>
+          <a:fillRef idx="1">
+            <a:schemeClr val="accent1"/>
+          </a:fillRef>
+          <a:effectRef idx="0">
+            <a:schemeClr val="accent1"/>
+          </a:effectRef>
+          <a:fontRef idx="minor">
+            <a:schemeClr val="lt1"/>
+          </a:fontRef>
+        </p:style>
+        <p:txBody>
+          <a:bodyPr rtlCol="0" anchor="ctr"/>
+          <a:lstStyle/>
+          <a:p>
+            <a:pPr algn="ctr"/>
+            <a:r>
+              <a:rPr lang="en-US" dirty="0">
+                <a:solidFill>
+                  <a:schemeClr val="tx1"/>
+                </a:solidFill>
+              </a:rPr>
+              <a:t>Tests + Eval Harness 10+ scenarios pass/fail summary</a:t>
+            </a:r>
+          </a:p>
+        </p:txBody>
+      </p:sp>
+      <p:cxnSp>
+        <p:nvCxnSpPr>
+          <p:cNvPr id="17" name="Elbow Connector 16">
+            <a:extLst>
+              <a:ext uri="{FF2B5EF4-FFF2-40B4-BE49-F238E27FC236}">
+                <a16:creationId xmlns:a16="http://schemas.microsoft.com/office/drawing/2014/main" id="{21087735-6954-02C9-91DA-9A84DC8A86F3}"/>
+              </a:ext>
+            </a:extLst>
+          </p:cNvPr>
+          <p:cNvCxnSpPr>
+            <a:cxnSpLocks/>
+          </p:cNvCxnSpPr>
+          <p:nvPr/>
+        </p:nvCxnSpPr>
+        <p:spPr>
+          <a:xfrm flipV="1">
+            <a:off x="2864552" y="4366012"/>
+            <a:ext cx="1556858" cy="1374948"/>
+          </a:xfrm>
+          <a:prstGeom prst="bentConnector2">
+            <a:avLst/>
+          </a:prstGeom>
+          <a:ln>
+            <a:solidFill>
+              <a:schemeClr val="tx1"/>
+            </a:solidFill>
+            <a:tailEnd type="stealth" w="lg" len="lg"/>
+          </a:ln>
+        </p:spPr>
+        <p:style>
+          <a:lnRef idx="2">
+            <a:schemeClr val="accent1"/>
+          </a:lnRef>
+          <a:fillRef idx="0">
+            <a:schemeClr val="accent1"/>
+          </a:fillRef>
+          <a:effectRef idx="1">
+            <a:schemeClr val="accent1"/>
+          </a:effectRef>
+          <a:fontRef idx="minor">
+            <a:schemeClr val="tx1"/>
+          </a:fontRef>
+        </p:style>
+      </p:cxnSp>
+      <p:sp>
+        <p:nvSpPr>
+          <p:cNvPr id="21" name="Rounded Rectangle 20">
+            <a:extLst>
+              <a:ext uri="{FF2B5EF4-FFF2-40B4-BE49-F238E27FC236}">
+                <a16:creationId xmlns:a16="http://schemas.microsoft.com/office/drawing/2014/main" id="{0C5C1AFD-7B30-A89C-853A-9A52443C43E0}"/>
+              </a:ext>
+            </a:extLst>
+          </p:cNvPr>
+          <p:cNvSpPr/>
+          <p:nvPr/>
+        </p:nvSpPr>
+        <p:spPr>
+          <a:xfrm>
+            <a:off x="5858006" y="4491292"/>
+            <a:ext cx="2211707" cy="861026"/>
+          </a:xfrm>
+          <a:prstGeom prst="roundRect">
+            <a:avLst/>
+          </a:prstGeom>
+          <a:solidFill>
+            <a:schemeClr val="accent5">
+              <a:lumMod val="20000"/>
+              <a:lumOff val="80000"/>
+            </a:schemeClr>
+          </a:solidFill>
+          <a:ln>
+            <a:solidFill>
+              <a:schemeClr val="accent5">
+                <a:lumMod val="20000"/>
+                <a:lumOff val="80000"/>
+              </a:schemeClr>
+            </a:solidFill>
+          </a:ln>
+        </p:spPr>
+        <p:style>
+          <a:lnRef idx="2">
+            <a:schemeClr val="accent1">
+              <a:shade val="15000"/>
+            </a:schemeClr>
+          </a:lnRef>
+          <a:fillRef idx="1">
+            <a:schemeClr val="accent1"/>
+          </a:fillRef>
+          <a:effectRef idx="0">
+            <a:schemeClr val="accent1"/>
+          </a:effectRef>
+          <a:fontRef idx="minor">
+            <a:schemeClr val="lt1"/>
+          </a:fontRef>
+        </p:style>
+        <p:txBody>
+          <a:bodyPr rtlCol="0" anchor="ctr"/>
+          <a:lstStyle/>
+          <a:p>
+            <a:pPr algn="ctr"/>
+            <a:r>
+              <a:rPr lang="en-US" dirty="0">
+                <a:solidFill>
+                  <a:schemeClr val="tx1"/>
+                </a:solidFill>
+              </a:rPr>
+              <a:t>Scheduler Tools add, list, conflicts slots, save/load</a:t>
+            </a:r>
+          </a:p>
+        </p:txBody>
+      </p:sp>
+      <p:sp>
+        <p:nvSpPr>
+          <p:cNvPr id="22" name="Rounded Rectangle 21">
+            <a:extLst>
+              <a:ext uri="{FF2B5EF4-FFF2-40B4-BE49-F238E27FC236}">
+                <a16:creationId xmlns:a16="http://schemas.microsoft.com/office/drawing/2014/main" id="{BA15AB32-2B72-241A-506D-3D525224A2E8}"/>
+              </a:ext>
+            </a:extLst>
+          </p:cNvPr>
+          <p:cNvSpPr/>
+          <p:nvPr/>
+        </p:nvSpPr>
+        <p:spPr>
+          <a:xfrm>
+            <a:off x="5858005" y="3199540"/>
+            <a:ext cx="2211706" cy="861026"/>
+          </a:xfrm>
+          <a:prstGeom prst="roundRect">
+            <a:avLst/>
+          </a:prstGeom>
+          <a:solidFill>
+            <a:schemeClr val="accent5">
+              <a:lumMod val="20000"/>
+              <a:lumOff val="80000"/>
+            </a:schemeClr>
+          </a:solidFill>
+          <a:ln>
+            <a:solidFill>
+              <a:schemeClr val="accent5">
+                <a:lumMod val="20000"/>
+                <a:lumOff val="80000"/>
+              </a:schemeClr>
+            </a:solidFill>
+          </a:ln>
+        </p:spPr>
+        <p:style>
+          <a:lnRef idx="2">
+            <a:schemeClr val="accent1">
+              <a:shade val="15000"/>
+            </a:schemeClr>
+          </a:lnRef>
+          <a:fillRef idx="1">
+            <a:schemeClr val="accent1"/>
+          </a:fillRef>
+          <a:effectRef idx="0">
+            <a:schemeClr val="accent1"/>
+          </a:effectRef>
+          <a:fontRef idx="minor">
+            <a:schemeClr val="lt1"/>
+          </a:fontRef>
+        </p:style>
+        <p:txBody>
+          <a:bodyPr rtlCol="0" anchor="ctr"/>
+          <a:lstStyle/>
+          <a:p>
+            <a:pPr algn="ctr"/>
+            <a:r>
+              <a:rPr lang="en-US" dirty="0">
+                <a:solidFill>
+                  <a:schemeClr val="tx1"/>
+                </a:solidFill>
+              </a:rPr>
+              <a:t>Model Selector deterministic, Gemini, Ollama</a:t>
+            </a:r>
+          </a:p>
+        </p:txBody>
+      </p:sp>
+      <p:sp>
+        <p:nvSpPr>
+          <p:cNvPr id="23" name="Rounded Rectangle 22">
+            <a:extLst>
+              <a:ext uri="{FF2B5EF4-FFF2-40B4-BE49-F238E27FC236}">
+                <a16:creationId xmlns:a16="http://schemas.microsoft.com/office/drawing/2014/main" id="{EA2A3AE3-8F19-7759-A5F8-EC2BC0EF0BB2}"/>
+              </a:ext>
+            </a:extLst>
+          </p:cNvPr>
+          <p:cNvSpPr/>
+          <p:nvPr/>
+        </p:nvSpPr>
+        <p:spPr>
+          <a:xfrm>
+            <a:off x="5858006" y="1890934"/>
+            <a:ext cx="2211705" cy="861026"/>
+          </a:xfrm>
+          <a:prstGeom prst="roundRect">
+            <a:avLst/>
+          </a:prstGeom>
+          <a:solidFill>
+            <a:srgbClr val="FFC000"/>
+          </a:solidFill>
+          <a:ln>
+            <a:solidFill>
+              <a:srgbClr val="FFC000"/>
+            </a:solidFill>
+          </a:ln>
+        </p:spPr>
+        <p:style>
+          <a:lnRef idx="2">
+            <a:schemeClr val="accent1">
+              <a:shade val="15000"/>
+            </a:schemeClr>
+          </a:lnRef>
+          <a:fillRef idx="1">
+            <a:schemeClr val="accent1"/>
+          </a:fillRef>
+          <a:effectRef idx="0">
+            <a:schemeClr val="accent1"/>
+          </a:effectRef>
+          <a:fontRef idx="minor">
+            <a:schemeClr val="lt1"/>
+          </a:fontRef>
+        </p:style>
+        <p:txBody>
+          <a:bodyPr rtlCol="0" anchor="ctr"/>
+          <a:lstStyle/>
+          <a:p>
+            <a:pPr algn="ctr"/>
+            <a:r>
+              <a:rPr lang="en-US" dirty="0">
+                <a:solidFill>
+                  <a:schemeClr val="tx1"/>
+                </a:solidFill>
+              </a:rPr>
+              <a:t>Retriever Selector TF-IDF or Gemini embeddings</a:t>
+            </a:r>
+          </a:p>
+        </p:txBody>
+      </p:sp>
+      <p:sp>
+        <p:nvSpPr>
+          <p:cNvPr id="24" name="Rounded Rectangle 23">
+            <a:extLst>
+              <a:ext uri="{FF2B5EF4-FFF2-40B4-BE49-F238E27FC236}">
+                <a16:creationId xmlns:a16="http://schemas.microsoft.com/office/drawing/2014/main" id="{88D7C8AD-5BAC-A1C3-B41C-D26AF3822C30}"/>
+              </a:ext>
+            </a:extLst>
+          </p:cNvPr>
+          <p:cNvSpPr/>
+          <p:nvPr/>
+        </p:nvSpPr>
+        <p:spPr>
+          <a:xfrm>
+            <a:off x="9669266" y="5324830"/>
+            <a:ext cx="2274183" cy="806050"/>
+          </a:xfrm>
+          <a:prstGeom prst="roundRect">
+            <a:avLst/>
+          </a:prstGeom>
+          <a:solidFill>
+            <a:schemeClr val="accent1">
+              <a:lumMod val="20000"/>
+              <a:lumOff val="80000"/>
+            </a:schemeClr>
+          </a:solidFill>
+          <a:ln>
+            <a:solidFill>
+              <a:schemeClr val="accent1">
+                <a:lumMod val="20000"/>
+                <a:lumOff val="80000"/>
+              </a:schemeClr>
+            </a:solidFill>
+          </a:ln>
+        </p:spPr>
+        <p:style>
+          <a:lnRef idx="2">
+            <a:schemeClr val="accent1">
+              <a:shade val="15000"/>
+            </a:schemeClr>
+          </a:lnRef>
+          <a:fillRef idx="1">
+            <a:schemeClr val="accent1"/>
+          </a:fillRef>
+          <a:effectRef idx="0">
+            <a:schemeClr val="accent1"/>
+          </a:effectRef>
+          <a:fontRef idx="minor">
+            <a:schemeClr val="lt1"/>
+          </a:fontRef>
+        </p:style>
+        <p:txBody>
+          <a:bodyPr rtlCol="0" anchor="ctr"/>
+          <a:lstStyle/>
+          <a:p>
+            <a:pPr algn="ctr"/>
+            <a:r>
+              <a:rPr lang="en-US" dirty="0">
+                <a:solidFill>
+                  <a:schemeClr val="tx1"/>
+                </a:solidFill>
+              </a:rPr>
+              <a:t>Tests + Eval Harness 10+ scenarios pass/fail summary</a:t>
+            </a:r>
+          </a:p>
+        </p:txBody>
+      </p:sp>
+      <p:sp>
+        <p:nvSpPr>
+          <p:cNvPr id="25" name="Rounded Rectangle 24">
+            <a:extLst>
+              <a:ext uri="{FF2B5EF4-FFF2-40B4-BE49-F238E27FC236}">
+                <a16:creationId xmlns:a16="http://schemas.microsoft.com/office/drawing/2014/main" id="{F08315A9-3F60-B02B-EB93-2AC795B8FE1B}"/>
+              </a:ext>
+            </a:extLst>
+          </p:cNvPr>
+          <p:cNvSpPr/>
+          <p:nvPr/>
+        </p:nvSpPr>
+        <p:spPr>
+          <a:xfrm>
+            <a:off x="9700505" y="3860791"/>
+            <a:ext cx="2211707" cy="861026"/>
+          </a:xfrm>
+          <a:prstGeom prst="roundRect">
+            <a:avLst/>
+          </a:prstGeom>
+          <a:solidFill>
+            <a:schemeClr val="accent5">
+              <a:lumMod val="20000"/>
+              <a:lumOff val="80000"/>
+            </a:schemeClr>
+          </a:solidFill>
+          <a:ln>
+            <a:solidFill>
+              <a:schemeClr val="accent5">
+                <a:lumMod val="20000"/>
+                <a:lumOff val="80000"/>
+              </a:schemeClr>
+            </a:solidFill>
+          </a:ln>
+        </p:spPr>
+        <p:style>
+          <a:lnRef idx="2">
+            <a:schemeClr val="accent1">
+              <a:shade val="15000"/>
+            </a:schemeClr>
+          </a:lnRef>
+          <a:fillRef idx="1">
+            <a:schemeClr val="accent1"/>
+          </a:fillRef>
+          <a:effectRef idx="0">
+            <a:schemeClr val="accent1"/>
+          </a:effectRef>
+          <a:fontRef idx="minor">
+            <a:schemeClr val="lt1"/>
+          </a:fontRef>
+        </p:style>
+        <p:txBody>
+          <a:bodyPr rtlCol="0" anchor="ctr"/>
+          <a:lstStyle/>
+          <a:p>
+            <a:pPr algn="ctr"/>
+            <a:r>
+              <a:rPr lang="en-US" dirty="0">
+                <a:solidFill>
+                  <a:schemeClr val="tx1"/>
+                </a:solidFill>
+              </a:rPr>
+              <a:t>Ollama Local API list models, pull chats/JSON</a:t>
+            </a:r>
+          </a:p>
+        </p:txBody>
+      </p:sp>
+      <p:sp>
+        <p:nvSpPr>
+          <p:cNvPr id="36" name="Rounded Rectangle 35">
+            <a:extLst>
+              <a:ext uri="{FF2B5EF4-FFF2-40B4-BE49-F238E27FC236}">
+                <a16:creationId xmlns:a16="http://schemas.microsoft.com/office/drawing/2014/main" id="{6A2C59C5-1AB0-FB0D-8E2C-33CAA5759C3A}"/>
+              </a:ext>
+            </a:extLst>
+          </p:cNvPr>
+          <p:cNvSpPr/>
+          <p:nvPr/>
+        </p:nvSpPr>
+        <p:spPr>
+          <a:xfrm>
+            <a:off x="9331890" y="2646262"/>
+            <a:ext cx="2580323" cy="861026"/>
+          </a:xfrm>
+          <a:prstGeom prst="roundRect">
+            <a:avLst/>
+          </a:prstGeom>
+          <a:solidFill>
+            <a:schemeClr val="accent5">
+              <a:lumMod val="20000"/>
+              <a:lumOff val="80000"/>
+            </a:schemeClr>
+          </a:solidFill>
+          <a:ln>
+            <a:solidFill>
+              <a:schemeClr val="accent5">
+                <a:lumMod val="20000"/>
+                <a:lumOff val="80000"/>
+              </a:schemeClr>
+            </a:solidFill>
+          </a:ln>
+        </p:spPr>
+        <p:style>
+          <a:lnRef idx="2">
+            <a:schemeClr val="accent1">
+              <a:shade val="15000"/>
+            </a:schemeClr>
+          </a:lnRef>
+          <a:fillRef idx="1">
+            <a:schemeClr val="accent1"/>
+          </a:fillRef>
+          <a:effectRef idx="0">
+            <a:schemeClr val="accent1"/>
+          </a:effectRef>
+          <a:fontRef idx="minor">
+            <a:schemeClr val="lt1"/>
+          </a:fontRef>
+        </p:style>
+        <p:txBody>
+          <a:bodyPr rtlCol="0" anchor="ctr"/>
+          <a:lstStyle/>
+          <a:p>
+            <a:pPr algn="ctr"/>
+            <a:r>
+              <a:rPr lang="en-US" dirty="0">
+                <a:solidFill>
+                  <a:schemeClr val="tx1"/>
+                </a:solidFill>
+              </a:rPr>
+              <a:t>Gemini API embeddings, generate structured JSON</a:t>
+            </a:r>
+          </a:p>
+        </p:txBody>
+      </p:sp>
+      <p:sp>
+        <p:nvSpPr>
+          <p:cNvPr id="37" name="Rounded Rectangle 36">
+            <a:extLst>
+              <a:ext uri="{FF2B5EF4-FFF2-40B4-BE49-F238E27FC236}">
+                <a16:creationId xmlns:a16="http://schemas.microsoft.com/office/drawing/2014/main" id="{65D2CBEE-18A3-8E60-F139-0C12B20B4AB6}"/>
+              </a:ext>
+            </a:extLst>
+          </p:cNvPr>
+          <p:cNvSpPr/>
+          <p:nvPr/>
+        </p:nvSpPr>
+        <p:spPr>
+          <a:xfrm>
+            <a:off x="9331889" y="1431733"/>
+            <a:ext cx="2580323" cy="861026"/>
+          </a:xfrm>
+          <a:prstGeom prst="roundRect">
+            <a:avLst/>
+          </a:prstGeom>
+          <a:solidFill>
+            <a:schemeClr val="bg1">
+              <a:lumMod val="85000"/>
+            </a:schemeClr>
+          </a:solidFill>
+          <a:ln>
+            <a:solidFill>
+              <a:schemeClr val="bg1">
+                <a:lumMod val="85000"/>
+              </a:schemeClr>
+            </a:solidFill>
+          </a:ln>
+        </p:spPr>
+        <p:style>
+          <a:lnRef idx="2">
+            <a:schemeClr val="accent1">
+              <a:shade val="15000"/>
+            </a:schemeClr>
+          </a:lnRef>
+          <a:fillRef idx="1">
+            <a:schemeClr val="accent1"/>
+          </a:fillRef>
+          <a:effectRef idx="0">
+            <a:schemeClr val="accent1"/>
+          </a:effectRef>
+          <a:fontRef idx="minor">
+            <a:schemeClr val="lt1"/>
+          </a:fontRef>
+        </p:style>
+        <p:txBody>
+          <a:bodyPr rtlCol="0" anchor="ctr"/>
+          <a:lstStyle/>
+          <a:p>
+            <a:pPr algn="ctr"/>
+            <a:r>
+              <a:rPr lang="en-US" dirty="0">
+                <a:solidFill>
+                  <a:schemeClr val="tx1"/>
+                </a:solidFill>
+              </a:rPr>
+              <a:t>Pet-Care KB feeding, exercise, grooming, warning signs</a:t>
+            </a:r>
+          </a:p>
+        </p:txBody>
+      </p:sp>
+      <p:cxnSp>
+        <p:nvCxnSpPr>
+          <p:cNvPr id="39" name="Elbow Connector 38">
+            <a:extLst>
+              <a:ext uri="{FF2B5EF4-FFF2-40B4-BE49-F238E27FC236}">
+                <a16:creationId xmlns:a16="http://schemas.microsoft.com/office/drawing/2014/main" id="{70C49E98-1B7F-2262-4E7A-A3C65E0B0B6A}"/>
+              </a:ext>
+            </a:extLst>
+          </p:cNvPr>
+          <p:cNvCxnSpPr>
+            <a:cxnSpLocks/>
+            <a:endCxn id="23" idx="1"/>
+          </p:cNvCxnSpPr>
+          <p:nvPr/>
+        </p:nvCxnSpPr>
+        <p:spPr>
+          <a:xfrm flipV="1">
+            <a:off x="4588284" y="2321447"/>
+            <a:ext cx="1269722" cy="1258345"/>
+          </a:xfrm>
+          <a:prstGeom prst="bentConnector3">
+            <a:avLst>
+              <a:gd name="adj1" fmla="val -312"/>
+            </a:avLst>
+          </a:prstGeom>
+          <a:ln>
+            <a:solidFill>
+              <a:schemeClr val="tx1"/>
+            </a:solidFill>
+            <a:tailEnd type="stealth" w="lg" len="lg"/>
+          </a:ln>
+        </p:spPr>
+        <p:style>
+          <a:lnRef idx="2">
+            <a:schemeClr val="accent1"/>
+          </a:lnRef>
+          <a:fillRef idx="0">
+            <a:schemeClr val="accent1"/>
+          </a:fillRef>
+          <a:effectRef idx="1">
+            <a:schemeClr val="accent1"/>
+          </a:effectRef>
+          <a:fontRef idx="minor">
+            <a:schemeClr val="tx1"/>
+          </a:fontRef>
+        </p:style>
+      </p:cxnSp>
+      <p:cxnSp>
+        <p:nvCxnSpPr>
+          <p:cNvPr id="46" name="Elbow Connector 45">
+            <a:extLst>
+              <a:ext uri="{FF2B5EF4-FFF2-40B4-BE49-F238E27FC236}">
+                <a16:creationId xmlns:a16="http://schemas.microsoft.com/office/drawing/2014/main" id="{0161A86B-276B-0B1A-FE27-DD36905940AB}"/>
+              </a:ext>
+            </a:extLst>
+          </p:cNvPr>
+          <p:cNvCxnSpPr>
+            <a:cxnSpLocks/>
+            <a:stCxn id="23" idx="0"/>
+          </p:cNvCxnSpPr>
+          <p:nvPr/>
+        </p:nvCxnSpPr>
+        <p:spPr>
+          <a:xfrm rot="5400000" flipH="1" flipV="1">
+            <a:off x="8026216" y="585261"/>
+            <a:ext cx="243316" cy="2368030"/>
+          </a:xfrm>
+          <a:prstGeom prst="bentConnector2">
+            <a:avLst/>
+          </a:prstGeom>
+          <a:ln>
+            <a:solidFill>
+              <a:schemeClr val="tx1"/>
+            </a:solidFill>
+            <a:tailEnd type="stealth" w="lg" len="lg"/>
+          </a:ln>
+        </p:spPr>
+        <p:style>
+          <a:lnRef idx="2">
+            <a:schemeClr val="accent1"/>
+          </a:lnRef>
+          <a:fillRef idx="0">
+            <a:schemeClr val="accent1"/>
+          </a:fillRef>
+          <a:effectRef idx="1">
+            <a:schemeClr val="accent1"/>
+          </a:effectRef>
+          <a:fontRef idx="minor">
+            <a:schemeClr val="tx1"/>
+          </a:fontRef>
+        </p:style>
+      </p:cxnSp>
+      <p:cxnSp>
+        <p:nvCxnSpPr>
+          <p:cNvPr id="48" name="Elbow Connector 47">
+            <a:extLst>
+              <a:ext uri="{FF2B5EF4-FFF2-40B4-BE49-F238E27FC236}">
+                <a16:creationId xmlns:a16="http://schemas.microsoft.com/office/drawing/2014/main" id="{212B3242-C515-4C38-BC7D-90DCB6F69712}"/>
+              </a:ext>
+            </a:extLst>
+          </p:cNvPr>
+          <p:cNvCxnSpPr>
+            <a:cxnSpLocks/>
+            <a:stCxn id="23" idx="3"/>
+          </p:cNvCxnSpPr>
+          <p:nvPr/>
+        </p:nvCxnSpPr>
+        <p:spPr>
+          <a:xfrm>
+            <a:off x="8069711" y="2321447"/>
+            <a:ext cx="1262178" cy="629172"/>
+          </a:xfrm>
+          <a:prstGeom prst="bentConnector3">
+            <a:avLst>
+              <a:gd name="adj1" fmla="val 20228"/>
+            </a:avLst>
+          </a:prstGeom>
+          <a:ln>
+            <a:solidFill>
+              <a:schemeClr val="tx1"/>
+            </a:solidFill>
+            <a:tailEnd type="stealth" w="lg" len="lg"/>
+          </a:ln>
+        </p:spPr>
+        <p:style>
+          <a:lnRef idx="2">
+            <a:schemeClr val="accent1"/>
+          </a:lnRef>
+          <a:fillRef idx="0">
+            <a:schemeClr val="accent1"/>
+          </a:fillRef>
+          <a:effectRef idx="1">
+            <a:schemeClr val="accent1"/>
+          </a:effectRef>
+          <a:fontRef idx="minor">
+            <a:schemeClr val="tx1"/>
+          </a:fontRef>
+        </p:style>
+      </p:cxnSp>
+      <p:cxnSp>
+        <p:nvCxnSpPr>
+          <p:cNvPr id="53" name="Elbow Connector 52">
+            <a:extLst>
+              <a:ext uri="{FF2B5EF4-FFF2-40B4-BE49-F238E27FC236}">
+                <a16:creationId xmlns:a16="http://schemas.microsoft.com/office/drawing/2014/main" id="{9D7354F5-C581-55A8-928B-06BF1A4CABBE}"/>
+              </a:ext>
+            </a:extLst>
+          </p:cNvPr>
+          <p:cNvCxnSpPr>
+            <a:cxnSpLocks/>
+            <a:endCxn id="36" idx="1"/>
+          </p:cNvCxnSpPr>
+          <p:nvPr/>
+        </p:nvCxnSpPr>
+        <p:spPr>
+          <a:xfrm flipV="1">
+            <a:off x="8069710" y="3076775"/>
+            <a:ext cx="1262180" cy="276173"/>
+          </a:xfrm>
+          <a:prstGeom prst="bentConnector3">
+            <a:avLst>
+              <a:gd name="adj1" fmla="val 20228"/>
+            </a:avLst>
+          </a:prstGeom>
+          <a:ln>
+            <a:solidFill>
+              <a:schemeClr val="tx1"/>
+            </a:solidFill>
+            <a:tailEnd type="stealth" w="lg" len="lg"/>
+          </a:ln>
+        </p:spPr>
+        <p:style>
+          <a:lnRef idx="2">
+            <a:schemeClr val="accent1"/>
+          </a:lnRef>
+          <a:fillRef idx="0">
+            <a:schemeClr val="accent1"/>
+          </a:fillRef>
+          <a:effectRef idx="1">
+            <a:schemeClr val="accent1"/>
+          </a:effectRef>
+          <a:fontRef idx="minor">
+            <a:schemeClr val="tx1"/>
+          </a:fontRef>
+        </p:style>
+      </p:cxnSp>
+      <p:cxnSp>
+        <p:nvCxnSpPr>
+          <p:cNvPr id="58" name="Elbow Connector 57">
+            <a:extLst>
+              <a:ext uri="{FF2B5EF4-FFF2-40B4-BE49-F238E27FC236}">
+                <a16:creationId xmlns:a16="http://schemas.microsoft.com/office/drawing/2014/main" id="{4275CFEC-AC57-8320-CE90-302343DA6963}"/>
+              </a:ext>
+            </a:extLst>
+          </p:cNvPr>
+          <p:cNvCxnSpPr>
+            <a:stCxn id="22" idx="3"/>
+            <a:endCxn id="25" idx="1"/>
+          </p:cNvCxnSpPr>
+          <p:nvPr/>
+        </p:nvCxnSpPr>
+        <p:spPr>
+          <a:xfrm>
+            <a:off x="8069711" y="3630053"/>
+            <a:ext cx="1630794" cy="661251"/>
+          </a:xfrm>
+          <a:prstGeom prst="bentConnector3">
+            <a:avLst>
+              <a:gd name="adj1" fmla="val 20812"/>
+            </a:avLst>
+          </a:prstGeom>
+          <a:ln>
+            <a:solidFill>
+              <a:schemeClr val="tx1"/>
+            </a:solidFill>
+            <a:tailEnd type="stealth" w="lg" len="lg"/>
+          </a:ln>
+        </p:spPr>
+        <p:style>
+          <a:lnRef idx="2">
+            <a:schemeClr val="accent1"/>
+          </a:lnRef>
+          <a:fillRef idx="0">
+            <a:schemeClr val="accent1"/>
+          </a:fillRef>
+          <a:effectRef idx="1">
+            <a:schemeClr val="accent1"/>
+          </a:effectRef>
+          <a:fontRef idx="minor">
+            <a:schemeClr val="tx1"/>
+          </a:fontRef>
+        </p:style>
+      </p:cxnSp>
+      <p:cxnSp>
+        <p:nvCxnSpPr>
+          <p:cNvPr id="62" name="Elbow Connector 61">
+            <a:extLst>
+              <a:ext uri="{FF2B5EF4-FFF2-40B4-BE49-F238E27FC236}">
+                <a16:creationId xmlns:a16="http://schemas.microsoft.com/office/drawing/2014/main" id="{CB94CCC3-ECB9-E598-CC43-A42CDC76EAE6}"/>
+              </a:ext>
+            </a:extLst>
+          </p:cNvPr>
+          <p:cNvCxnSpPr>
+            <a:stCxn id="21" idx="3"/>
+            <a:endCxn id="24" idx="0"/>
+          </p:cNvCxnSpPr>
+          <p:nvPr/>
+        </p:nvCxnSpPr>
+        <p:spPr>
+          <a:xfrm>
+            <a:off x="8069713" y="4921805"/>
+            <a:ext cx="2736645" cy="403025"/>
+          </a:xfrm>
+          <a:prstGeom prst="bentConnector2">
+            <a:avLst/>
+          </a:prstGeom>
+          <a:ln>
+            <a:solidFill>
+              <a:schemeClr val="tx1"/>
+            </a:solidFill>
+            <a:tailEnd type="stealth" w="lg" len="lg"/>
+          </a:ln>
+        </p:spPr>
+        <p:style>
+          <a:lnRef idx="2">
+            <a:schemeClr val="accent1"/>
+          </a:lnRef>
+          <a:fillRef idx="0">
+            <a:schemeClr val="accent1"/>
+          </a:fillRef>
+          <a:effectRef idx="1">
+            <a:schemeClr val="accent1"/>
+          </a:effectRef>
+          <a:fontRef idx="minor">
+            <a:schemeClr val="tx1"/>
+          </a:fontRef>
+        </p:style>
+      </p:cxnSp>
+      <p:cxnSp>
+        <p:nvCxnSpPr>
+          <p:cNvPr id="64" name="Elbow Connector 63">
+            <a:extLst>
+              <a:ext uri="{FF2B5EF4-FFF2-40B4-BE49-F238E27FC236}">
+                <a16:creationId xmlns:a16="http://schemas.microsoft.com/office/drawing/2014/main" id="{65DB3E03-7B42-B9B8-A50E-E5BA8B1A50FB}"/>
+              </a:ext>
+            </a:extLst>
+          </p:cNvPr>
+          <p:cNvCxnSpPr>
+            <a:cxnSpLocks/>
+            <a:endCxn id="22" idx="1"/>
+          </p:cNvCxnSpPr>
+          <p:nvPr/>
+        </p:nvCxnSpPr>
+        <p:spPr>
+          <a:xfrm flipV="1">
+            <a:off x="5313878" y="3630053"/>
+            <a:ext cx="544127" cy="203808"/>
+          </a:xfrm>
+          <a:prstGeom prst="bentConnector3">
+            <a:avLst/>
+          </a:prstGeom>
+          <a:ln>
+            <a:solidFill>
+              <a:schemeClr val="tx1"/>
+            </a:solidFill>
+            <a:tailEnd type="stealth" w="lg" len="lg"/>
+          </a:ln>
+        </p:spPr>
+        <p:style>
+          <a:lnRef idx="2">
+            <a:schemeClr val="accent1"/>
+          </a:lnRef>
+          <a:fillRef idx="0">
+            <a:schemeClr val="accent1"/>
+          </a:fillRef>
+          <a:effectRef idx="1">
+            <a:schemeClr val="accent1"/>
+          </a:effectRef>
+          <a:fontRef idx="minor">
+            <a:schemeClr val="tx1"/>
+          </a:fontRef>
+        </p:style>
+      </p:cxnSp>
+      <p:cxnSp>
+        <p:nvCxnSpPr>
+          <p:cNvPr id="66" name="Elbow Connector 65">
+            <a:extLst>
+              <a:ext uri="{FF2B5EF4-FFF2-40B4-BE49-F238E27FC236}">
+                <a16:creationId xmlns:a16="http://schemas.microsoft.com/office/drawing/2014/main" id="{57A9B777-A0ED-A09A-C74F-91E3FDA04C13}"/>
+              </a:ext>
+            </a:extLst>
+          </p:cNvPr>
+          <p:cNvCxnSpPr>
+            <a:cxnSpLocks/>
+            <a:stCxn id="10" idx="3"/>
+            <a:endCxn id="21" idx="1"/>
+          </p:cNvCxnSpPr>
+          <p:nvPr/>
+        </p:nvCxnSpPr>
+        <p:spPr>
+          <a:xfrm>
+            <a:off x="5282640" y="4046395"/>
+            <a:ext cx="575366" cy="875410"/>
+          </a:xfrm>
+          <a:prstGeom prst="bentConnector3">
+            <a:avLst>
+              <a:gd name="adj1" fmla="val 50000"/>
+            </a:avLst>
+          </a:prstGeom>
+          <a:ln>
+            <a:solidFill>
+              <a:schemeClr val="tx1"/>
+            </a:solidFill>
+            <a:tailEnd type="stealth" w="lg" len="lg"/>
+          </a:ln>
+        </p:spPr>
+        <p:style>
+          <a:lnRef idx="2">
+            <a:schemeClr val="accent1"/>
+          </a:lnRef>
+          <a:fillRef idx="0">
+            <a:schemeClr val="accent1"/>
+          </a:fillRef>
+          <a:effectRef idx="1">
+            <a:schemeClr val="accent1"/>
+          </a:effectRef>
+          <a:fontRef idx="minor">
+            <a:schemeClr val="tx1"/>
+          </a:fontRef>
+        </p:style>
+      </p:cxnSp>
+      <p:cxnSp>
+        <p:nvCxnSpPr>
+          <p:cNvPr id="68" name="Elbow Connector 67">
+            <a:extLst>
+              <a:ext uri="{FF2B5EF4-FFF2-40B4-BE49-F238E27FC236}">
+                <a16:creationId xmlns:a16="http://schemas.microsoft.com/office/drawing/2014/main" id="{002F70EA-6E69-8157-6D39-B3322F834CEE}"/>
+              </a:ext>
+            </a:extLst>
+          </p:cNvPr>
+          <p:cNvCxnSpPr>
+            <a:cxnSpLocks/>
+            <a:stCxn id="24" idx="1"/>
+          </p:cNvCxnSpPr>
+          <p:nvPr/>
+        </p:nvCxnSpPr>
+        <p:spPr>
+          <a:xfrm rot="10800000">
+            <a:off x="4748834" y="4500451"/>
+            <a:ext cx="4920432" cy="1227404"/>
+          </a:xfrm>
+          <a:prstGeom prst="bentConnector3">
+            <a:avLst>
+              <a:gd name="adj1" fmla="val 99896"/>
+            </a:avLst>
+          </a:prstGeom>
+          <a:ln>
+            <a:solidFill>
+              <a:schemeClr val="tx1"/>
+            </a:solidFill>
+            <a:tailEnd type="stealth" w="lg" len="lg"/>
+          </a:ln>
+        </p:spPr>
+        <p:style>
+          <a:lnRef idx="2">
+            <a:schemeClr val="accent1"/>
+          </a:lnRef>
+          <a:fillRef idx="0">
+            <a:schemeClr val="accent1"/>
+          </a:fillRef>
+          <a:effectRef idx="1">
+            <a:schemeClr val="accent1"/>
+          </a:effectRef>
+          <a:fontRef idx="minor">
+            <a:schemeClr val="tx1"/>
+          </a:fontRef>
+        </p:style>
+      </p:cxnSp>
+      <p:cxnSp>
+        <p:nvCxnSpPr>
+          <p:cNvPr id="73" name="Straight Arrow Connector 72">
+            <a:extLst>
+              <a:ext uri="{FF2B5EF4-FFF2-40B4-BE49-F238E27FC236}">
+                <a16:creationId xmlns:a16="http://schemas.microsoft.com/office/drawing/2014/main" id="{D709E9D9-E206-BB36-FE5D-D791C80FECC9}"/>
+              </a:ext>
+            </a:extLst>
+          </p:cNvPr>
+          <p:cNvCxnSpPr>
+            <a:cxnSpLocks/>
+          </p:cNvCxnSpPr>
+          <p:nvPr/>
+        </p:nvCxnSpPr>
+        <p:spPr>
+          <a:xfrm>
+            <a:off x="2852585" y="6012494"/>
+            <a:ext cx="6816681" cy="0"/>
+          </a:xfrm>
+          <a:prstGeom prst="straightConnector1">
+            <a:avLst/>
+          </a:prstGeom>
+          <a:ln>
+            <a:solidFill>
+              <a:schemeClr val="tx1"/>
+            </a:solidFill>
+            <a:tailEnd type="stealth" w="lg" len="lg"/>
+          </a:ln>
+        </p:spPr>
+        <p:style>
+          <a:lnRef idx="2">
+            <a:schemeClr val="accent1"/>
+          </a:lnRef>
+          <a:fillRef idx="0">
+            <a:schemeClr val="accent1"/>
+          </a:fillRef>
+          <a:effectRef idx="1">
+            <a:schemeClr val="accent1"/>
+          </a:effectRef>
+          <a:fontRef idx="minor">
+            <a:schemeClr val="tx1"/>
+          </a:fontRef>
+        </p:style>
+      </p:cxnSp>
+      <p:sp>
+        <p:nvSpPr>
+          <p:cNvPr id="74" name="TextBox 73">
+            <a:extLst>
+              <a:ext uri="{FF2B5EF4-FFF2-40B4-BE49-F238E27FC236}">
+                <a16:creationId xmlns:a16="http://schemas.microsoft.com/office/drawing/2014/main" id="{56EC66FA-9BF9-7EDD-EE79-0953BFC8E609}"/>
+              </a:ext>
+            </a:extLst>
+          </p:cNvPr>
+          <p:cNvSpPr txBox="1"/>
+          <p:nvPr/>
+        </p:nvSpPr>
+        <p:spPr>
+          <a:xfrm>
+            <a:off x="114440" y="2765453"/>
+            <a:ext cx="927925" cy="369332"/>
+          </a:xfrm>
+          <a:prstGeom prst="rect">
+            <a:avLst/>
+          </a:prstGeom>
+          <a:noFill/>
+        </p:spPr>
+        <p:txBody>
+          <a:bodyPr wrap="square" rtlCol="0">
+            <a:spAutoFit/>
+          </a:bodyPr>
+          <a:lstStyle/>
+          <a:p>
+            <a:pPr algn="ctr"/>
+            <a:r>
+              <a:rPr lang="en-US" dirty="0"/>
+              <a:t>Input</a:t>
+            </a:r>
+          </a:p>
+        </p:txBody>
+      </p:sp>
+      <p:sp>
+        <p:nvSpPr>
+          <p:cNvPr id="75" name="TextBox 74">
+            <a:extLst>
+              <a:ext uri="{FF2B5EF4-FFF2-40B4-BE49-F238E27FC236}">
+                <a16:creationId xmlns:a16="http://schemas.microsoft.com/office/drawing/2014/main" id="{95F6D41C-B166-31D3-C69E-5B07089152AC}"/>
+              </a:ext>
+            </a:extLst>
+          </p:cNvPr>
+          <p:cNvSpPr txBox="1"/>
+          <p:nvPr/>
+        </p:nvSpPr>
+        <p:spPr>
+          <a:xfrm>
+            <a:off x="3351439" y="2316917"/>
+            <a:ext cx="1109448" cy="646331"/>
+          </a:xfrm>
+          <a:prstGeom prst="rect">
+            <a:avLst/>
+          </a:prstGeom>
+          <a:noFill/>
+        </p:spPr>
+        <p:txBody>
+          <a:bodyPr wrap="square" rtlCol="0">
+            <a:spAutoFit/>
+          </a:bodyPr>
+          <a:lstStyle/>
+          <a:p>
+            <a:pPr algn="ctr"/>
+            <a:r>
+              <a:rPr lang="en-US" dirty="0"/>
+              <a:t>Safe request</a:t>
+            </a:r>
+          </a:p>
+        </p:txBody>
+      </p:sp>
+      <p:sp>
+        <p:nvSpPr>
+          <p:cNvPr id="76" name="TextBox 75">
+            <a:extLst>
+              <a:ext uri="{FF2B5EF4-FFF2-40B4-BE49-F238E27FC236}">
+                <a16:creationId xmlns:a16="http://schemas.microsoft.com/office/drawing/2014/main" id="{1630E5FE-FA15-D8A7-7328-9B7F9FC7308A}"/>
+              </a:ext>
+            </a:extLst>
+          </p:cNvPr>
+          <p:cNvSpPr txBox="1"/>
+          <p:nvPr/>
+        </p:nvSpPr>
+        <p:spPr>
+          <a:xfrm>
+            <a:off x="1564575" y="4058822"/>
+            <a:ext cx="1971670" cy="369332"/>
+          </a:xfrm>
+          <a:prstGeom prst="rect">
+            <a:avLst/>
+          </a:prstGeom>
+          <a:noFill/>
+        </p:spPr>
+        <p:txBody>
+          <a:bodyPr wrap="square" rtlCol="0">
+            <a:spAutoFit/>
+          </a:bodyPr>
+          <a:lstStyle/>
+          <a:p>
+            <a:pPr algn="ctr"/>
+            <a:r>
+              <a:rPr lang="en-US" dirty="0"/>
+              <a:t>Answer + trace</a:t>
+            </a:r>
+          </a:p>
+        </p:txBody>
+      </p:sp>
+      <p:sp>
+        <p:nvSpPr>
+          <p:cNvPr id="77" name="TextBox 76">
+            <a:extLst>
+              <a:ext uri="{FF2B5EF4-FFF2-40B4-BE49-F238E27FC236}">
+                <a16:creationId xmlns:a16="http://schemas.microsoft.com/office/drawing/2014/main" id="{A302DF91-EF87-351C-D37F-66AFF281423A}"/>
+              </a:ext>
+            </a:extLst>
+          </p:cNvPr>
+          <p:cNvSpPr txBox="1"/>
+          <p:nvPr/>
+        </p:nvSpPr>
+        <p:spPr>
+          <a:xfrm>
+            <a:off x="3021132" y="5347781"/>
+            <a:ext cx="1237321" cy="369332"/>
+          </a:xfrm>
+          <a:prstGeom prst="rect">
+            <a:avLst/>
+          </a:prstGeom>
+          <a:noFill/>
+        </p:spPr>
+        <p:txBody>
+          <a:bodyPr wrap="square" rtlCol="0">
+            <a:spAutoFit/>
+          </a:bodyPr>
+          <a:lstStyle/>
+          <a:p>
+            <a:pPr algn="ctr"/>
+            <a:r>
+              <a:rPr lang="en-US" dirty="0"/>
+              <a:t>scenarios</a:t>
+            </a:r>
+          </a:p>
+        </p:txBody>
+      </p:sp>
+      <p:sp>
+        <p:nvSpPr>
+          <p:cNvPr id="82" name="TextBox 81">
+            <a:extLst>
+              <a:ext uri="{FF2B5EF4-FFF2-40B4-BE49-F238E27FC236}">
+                <a16:creationId xmlns:a16="http://schemas.microsoft.com/office/drawing/2014/main" id="{AC2F8760-DE83-D83F-0806-819B5C35CC74}"/>
+              </a:ext>
+            </a:extLst>
+          </p:cNvPr>
+          <p:cNvSpPr txBox="1"/>
+          <p:nvPr/>
+        </p:nvSpPr>
+        <p:spPr>
+          <a:xfrm>
+            <a:off x="5126768" y="5983075"/>
+            <a:ext cx="1237321" cy="369332"/>
+          </a:xfrm>
+          <a:prstGeom prst="rect">
+            <a:avLst/>
+          </a:prstGeom>
+          <a:noFill/>
+        </p:spPr>
+        <p:txBody>
+          <a:bodyPr wrap="square" rtlCol="0">
+            <a:spAutoFit/>
+          </a:bodyPr>
+          <a:lstStyle/>
+          <a:p>
+            <a:pPr algn="ctr"/>
+            <a:r>
+              <a:rPr lang="en-US" dirty="0"/>
+              <a:t>Unit tests</a:t>
+            </a:r>
+          </a:p>
+        </p:txBody>
+      </p:sp>
+      <p:sp>
+        <p:nvSpPr>
+          <p:cNvPr id="83" name="TextBox 82">
+            <a:extLst>
+              <a:ext uri="{FF2B5EF4-FFF2-40B4-BE49-F238E27FC236}">
+                <a16:creationId xmlns:a16="http://schemas.microsoft.com/office/drawing/2014/main" id="{5C3816FA-8A56-DB2F-4495-DC240C1C3A1A}"/>
+              </a:ext>
+            </a:extLst>
+          </p:cNvPr>
+          <p:cNvSpPr txBox="1"/>
+          <p:nvPr/>
+        </p:nvSpPr>
+        <p:spPr>
+          <a:xfrm>
+            <a:off x="5971380" y="5411486"/>
+            <a:ext cx="2003499" cy="369332"/>
+          </a:xfrm>
+          <a:prstGeom prst="rect">
+            <a:avLst/>
+          </a:prstGeom>
+          <a:noFill/>
+        </p:spPr>
+        <p:txBody>
+          <a:bodyPr wrap="square" rtlCol="0">
+            <a:spAutoFit/>
+          </a:bodyPr>
+          <a:lstStyle/>
+          <a:p>
+            <a:pPr algn="ctr"/>
+            <a:r>
+              <a:rPr lang="en-US" dirty="0"/>
+              <a:t>Schedule context</a:t>
+            </a:r>
+          </a:p>
+        </p:txBody>
+      </p:sp>
+      <p:sp>
+        <p:nvSpPr>
+          <p:cNvPr id="84" name="TextBox 83">
+            <a:extLst>
+              <a:ext uri="{FF2B5EF4-FFF2-40B4-BE49-F238E27FC236}">
+                <a16:creationId xmlns:a16="http://schemas.microsoft.com/office/drawing/2014/main" id="{409777DE-CD63-303B-BF57-0985F4C44C12}"/>
+              </a:ext>
+            </a:extLst>
+          </p:cNvPr>
+          <p:cNvSpPr txBox="1"/>
+          <p:nvPr/>
+        </p:nvSpPr>
+        <p:spPr>
+          <a:xfrm>
+            <a:off x="8148741" y="4601372"/>
+            <a:ext cx="1237321" cy="369332"/>
+          </a:xfrm>
+          <a:prstGeom prst="rect">
+            <a:avLst/>
+          </a:prstGeom>
+          <a:noFill/>
+        </p:spPr>
+        <p:txBody>
+          <a:bodyPr wrap="square" rtlCol="0">
+            <a:spAutoFit/>
+          </a:bodyPr>
+          <a:lstStyle/>
+          <a:p>
+            <a:pPr algn="ctr"/>
+            <a:r>
+              <a:rPr lang="en-US" dirty="0"/>
+              <a:t>actions</a:t>
+            </a:r>
+          </a:p>
+        </p:txBody>
+      </p:sp>
+      <p:sp>
+        <p:nvSpPr>
+          <p:cNvPr id="86" name="TextBox 85">
+            <a:extLst>
+              <a:ext uri="{FF2B5EF4-FFF2-40B4-BE49-F238E27FC236}">
+                <a16:creationId xmlns:a16="http://schemas.microsoft.com/office/drawing/2014/main" id="{82B29144-AD21-8F34-48D1-CBAC7ED9E79C}"/>
+              </a:ext>
+            </a:extLst>
+          </p:cNvPr>
+          <p:cNvSpPr txBox="1"/>
+          <p:nvPr/>
+        </p:nvSpPr>
+        <p:spPr>
+          <a:xfrm>
+            <a:off x="8232116" y="3877914"/>
+            <a:ext cx="1499628" cy="369332"/>
+          </a:xfrm>
+          <a:prstGeom prst="rect">
+            <a:avLst/>
+          </a:prstGeom>
+          <a:noFill/>
+        </p:spPr>
+        <p:txBody>
+          <a:bodyPr wrap="square" rtlCol="0">
+            <a:spAutoFit/>
+          </a:bodyPr>
+          <a:lstStyle/>
+          <a:p>
+            <a:pPr algn="ctr"/>
+            <a:r>
+              <a:rPr lang="en-US" dirty="0"/>
+              <a:t>Local</a:t>
+            </a:r>
+          </a:p>
+        </p:txBody>
+      </p:sp>
+      <p:sp>
+        <p:nvSpPr>
+          <p:cNvPr id="88" name="TextBox 87">
+            <a:extLst>
+              <a:ext uri="{FF2B5EF4-FFF2-40B4-BE49-F238E27FC236}">
+                <a16:creationId xmlns:a16="http://schemas.microsoft.com/office/drawing/2014/main" id="{4ACF1223-57E9-AC4D-B38E-DCFE0B3549A0}"/>
+              </a:ext>
+            </a:extLst>
+          </p:cNvPr>
+          <p:cNvSpPr txBox="1"/>
+          <p:nvPr/>
+        </p:nvSpPr>
+        <p:spPr>
+          <a:xfrm>
+            <a:off x="8135294" y="3067494"/>
+            <a:ext cx="1499628" cy="369332"/>
+          </a:xfrm>
+          <a:prstGeom prst="rect">
+            <a:avLst/>
+          </a:prstGeom>
+          <a:noFill/>
+        </p:spPr>
+        <p:txBody>
+          <a:bodyPr wrap="square" rtlCol="0">
+            <a:spAutoFit/>
+          </a:bodyPr>
+          <a:lstStyle/>
+          <a:p>
+            <a:pPr algn="ctr"/>
+            <a:r>
+              <a:rPr lang="en-US" dirty="0"/>
+              <a:t>Cloud</a:t>
+            </a:r>
+          </a:p>
+        </p:txBody>
+      </p:sp>
+      <p:sp>
+        <p:nvSpPr>
+          <p:cNvPr id="90" name="TextBox 89">
+            <a:extLst>
+              <a:ext uri="{FF2B5EF4-FFF2-40B4-BE49-F238E27FC236}">
+                <a16:creationId xmlns:a16="http://schemas.microsoft.com/office/drawing/2014/main" id="{AAED9C47-C317-1C8A-43D2-2F51DA155005}"/>
+              </a:ext>
+            </a:extLst>
+          </p:cNvPr>
+          <p:cNvSpPr txBox="1"/>
+          <p:nvPr/>
+        </p:nvSpPr>
+        <p:spPr>
+          <a:xfrm>
+            <a:off x="8086391" y="2327529"/>
+            <a:ext cx="1499628" cy="646331"/>
+          </a:xfrm>
+          <a:prstGeom prst="rect">
+            <a:avLst/>
+          </a:prstGeom>
+          <a:noFill/>
+        </p:spPr>
+        <p:txBody>
+          <a:bodyPr wrap="square" rtlCol="0">
+            <a:spAutoFit/>
+          </a:bodyPr>
+          <a:lstStyle/>
+          <a:p>
+            <a:pPr algn="ctr"/>
+            <a:r>
+              <a:rPr lang="en-US" dirty="0"/>
+              <a:t>Semantic Search</a:t>
+            </a:r>
+          </a:p>
+        </p:txBody>
+      </p:sp>
+      <p:sp>
+        <p:nvSpPr>
+          <p:cNvPr id="91" name="TextBox 90">
+            <a:extLst>
+              <a:ext uri="{FF2B5EF4-FFF2-40B4-BE49-F238E27FC236}">
+                <a16:creationId xmlns:a16="http://schemas.microsoft.com/office/drawing/2014/main" id="{ABA9BBC5-06A4-3704-A906-1AF9FB0A1367}"/>
+              </a:ext>
+            </a:extLst>
+          </p:cNvPr>
+          <p:cNvSpPr txBox="1"/>
+          <p:nvPr/>
+        </p:nvSpPr>
+        <p:spPr>
+          <a:xfrm>
+            <a:off x="7574911" y="1302598"/>
+            <a:ext cx="1499628" cy="369332"/>
+          </a:xfrm>
+          <a:prstGeom prst="rect">
+            <a:avLst/>
+          </a:prstGeom>
+          <a:noFill/>
+        </p:spPr>
+        <p:txBody>
+          <a:bodyPr wrap="square" rtlCol="0">
+            <a:spAutoFit/>
+          </a:bodyPr>
+          <a:lstStyle/>
+          <a:p>
+            <a:pPr algn="ctr"/>
+            <a:r>
+              <a:rPr lang="en-US" dirty="0"/>
+              <a:t>Local docs</a:t>
+            </a:r>
+          </a:p>
+        </p:txBody>
+      </p:sp>
+      <p:sp>
+        <p:nvSpPr>
+          <p:cNvPr id="92" name="TextBox 91">
+            <a:extLst>
+              <a:ext uri="{FF2B5EF4-FFF2-40B4-BE49-F238E27FC236}">
+                <a16:creationId xmlns:a16="http://schemas.microsoft.com/office/drawing/2014/main" id="{B9422A8B-0A64-B0AA-F926-9B0CF2677EBB}"/>
+              </a:ext>
+            </a:extLst>
+          </p:cNvPr>
+          <p:cNvSpPr txBox="1"/>
+          <p:nvPr/>
+        </p:nvSpPr>
+        <p:spPr>
+          <a:xfrm>
+            <a:off x="4639728" y="1957965"/>
+            <a:ext cx="1236854" cy="369332"/>
+          </a:xfrm>
+          <a:prstGeom prst="rect">
+            <a:avLst/>
+          </a:prstGeom>
+          <a:noFill/>
+        </p:spPr>
+        <p:txBody>
+          <a:bodyPr wrap="square" rtlCol="0">
+            <a:spAutoFit/>
+          </a:bodyPr>
+          <a:lstStyle/>
+          <a:p>
+            <a:pPr algn="ctr"/>
+            <a:r>
+              <a:rPr lang="en-US" dirty="0"/>
+              <a:t>retrieve</a:t>
+            </a:r>
+          </a:p>
+        </p:txBody>
+      </p:sp>
+      <p:sp>
+        <p:nvSpPr>
+          <p:cNvPr id="93" name="TextBox 92">
+            <a:extLst>
+              <a:ext uri="{FF2B5EF4-FFF2-40B4-BE49-F238E27FC236}">
+                <a16:creationId xmlns:a16="http://schemas.microsoft.com/office/drawing/2014/main" id="{2AECA803-21A6-54B6-491A-5F5749994A22}"/>
+              </a:ext>
+            </a:extLst>
+          </p:cNvPr>
+          <p:cNvSpPr txBox="1"/>
+          <p:nvPr/>
+        </p:nvSpPr>
+        <p:spPr>
+          <a:xfrm>
+            <a:off x="4621149" y="2961875"/>
+            <a:ext cx="1236854" cy="646331"/>
+          </a:xfrm>
+          <a:prstGeom prst="rect">
+            <a:avLst/>
+          </a:prstGeom>
+          <a:noFill/>
+        </p:spPr>
+        <p:txBody>
+          <a:bodyPr wrap="square" rtlCol="0">
+            <a:spAutoFit/>
+          </a:bodyPr>
+          <a:lstStyle/>
+          <a:p>
+            <a:pPr algn="ctr"/>
+            <a:r>
+              <a:rPr lang="en-US" dirty="0"/>
+              <a:t>Select backend</a:t>
+            </a:r>
+          </a:p>
+        </p:txBody>
+      </p:sp>
+      <p:sp>
+        <p:nvSpPr>
+          <p:cNvPr id="101" name="TextBox 100">
+            <a:extLst>
+              <a:ext uri="{FF2B5EF4-FFF2-40B4-BE49-F238E27FC236}">
+                <a16:creationId xmlns:a16="http://schemas.microsoft.com/office/drawing/2014/main" id="{DF5AC069-A0C2-A744-2C31-20CA4050A364}"/>
+              </a:ext>
+            </a:extLst>
+          </p:cNvPr>
+          <p:cNvSpPr txBox="1"/>
+          <p:nvPr/>
+        </p:nvSpPr>
+        <p:spPr>
+          <a:xfrm>
+            <a:off x="5477573" y="4101535"/>
+            <a:ext cx="1236854" cy="369332"/>
+          </a:xfrm>
+          <a:prstGeom prst="rect">
+            <a:avLst/>
+          </a:prstGeom>
+          <a:noFill/>
+        </p:spPr>
+        <p:txBody>
+          <a:bodyPr wrap="square" rtlCol="0">
+            <a:spAutoFit/>
+          </a:bodyPr>
+          <a:lstStyle/>
+          <a:p>
+            <a:pPr algn="ctr"/>
+            <a:r>
+              <a:rPr lang="en-US" dirty="0"/>
+              <a:t>Root calls</a:t>
+            </a:r>
+          </a:p>
+        </p:txBody>
+      </p:sp>
+      <p:sp>
+        <p:nvSpPr>
+          <p:cNvPr id="102" name="TextBox 101">
+            <a:extLst>
+              <a:ext uri="{FF2B5EF4-FFF2-40B4-BE49-F238E27FC236}">
+                <a16:creationId xmlns:a16="http://schemas.microsoft.com/office/drawing/2014/main" id="{077A5DFA-941C-0205-215C-2FAB3E81C86F}"/>
+              </a:ext>
+            </a:extLst>
+          </p:cNvPr>
+          <p:cNvSpPr txBox="1"/>
+          <p:nvPr/>
+        </p:nvSpPr>
+        <p:spPr>
+          <a:xfrm>
+            <a:off x="0" y="6367190"/>
+            <a:ext cx="12192000" cy="338554"/>
+          </a:xfrm>
+          <a:prstGeom prst="rect">
+            <a:avLst/>
+          </a:prstGeom>
+          <a:noFill/>
+        </p:spPr>
+        <p:txBody>
+          <a:bodyPr wrap="square" rtlCol="0">
+            <a:spAutoFit/>
+          </a:bodyPr>
+          <a:lstStyle/>
+          <a:p>
+            <a:pPr algn="ctr"/>
+            <a:r>
+              <a:rPr lang="en-US" sz="1600" b="1" dirty="0"/>
+              <a:t>Key idea: </a:t>
+            </a:r>
+            <a:r>
+              <a:rPr lang="en-US" sz="1600" dirty="0"/>
+              <a:t>The assistant uses the same scheduler backend as the UI, so the AI feature is integrated into the real application workflow.</a:t>
+            </a:r>
+          </a:p>
+        </p:txBody>
+      </p:sp>
+    </p:spTree>
+    <p:extLst>
+      <p:ext uri="{BB962C8B-B14F-4D97-AF65-F5344CB8AC3E}">
+        <p14:creationId xmlns:p14="http://schemas.microsoft.com/office/powerpoint/2010/main" val="1007242701"/>
+      </p:ext>
+    </p:extLst>
+  </p:cSld>
+  <p:clrMapOvr>
+    <a:masterClrMapping/>
+  </p:clrMapOvr>
+</p:sld>
+</file>
+
+<file path=ppt/slides/slide5.xml><?xml version="1.0" encoding="utf-8"?>
+<p:sld xmlns:a="http://schemas.openxmlformats.org/drawingml/2006/main" xmlns:r="http://schemas.openxmlformats.org/officeDocument/2006/relationships" xmlns:p="http://schemas.openxmlformats.org/presentationml/2006/main">
+  <p:cSld>
+    <p:spTree>
+      <p:nvGrpSpPr>
+        <p:cNvPr id="1" name=""/>
+        <p:cNvGrpSpPr/>
+        <p:nvPr/>
+      </p:nvGrpSpPr>
+      <p:grpSpPr>
+        <a:xfrm>
+          <a:off x="0" y="0"/>
+          <a:ext cx="0" cy="0"/>
+          <a:chOff x="0" y="0"/>
+          <a:chExt cx="0" cy="0"/>
+        </a:xfrm>
+      </p:grpSpPr>
+      <p:sp>
+        <p:nvSpPr>
+          <p:cNvPr id="2" name="Title 1">
+            <a:extLst>
+              <a:ext uri="{FF2B5EF4-FFF2-40B4-BE49-F238E27FC236}">
+                <a16:creationId xmlns:a16="http://schemas.microsoft.com/office/drawing/2014/main" id="{95A88430-D4AD-BEC4-B614-5F18806A93D1}"/>
+              </a:ext>
+            </a:extLst>
+          </p:cNvPr>
+          <p:cNvSpPr>
+            <a:spLocks noGrp="1"/>
+          </p:cNvSpPr>
+          <p:nvPr>
+            <p:ph type="title"/>
+          </p:nvPr>
+        </p:nvSpPr>
+        <p:spPr>
+          <a:xfrm>
+            <a:off x="838200" y="365126"/>
+            <a:ext cx="10515600" cy="791646"/>
+          </a:xfrm>
+        </p:spPr>
+        <p:txBody>
+          <a:bodyPr/>
+          <a:lstStyle/>
+          <a:p>
+            <a:r>
+              <a:rPr lang="en-US" dirty="0"/>
+              <a:t>Demo Plan: Three Inputs</a:t>
+            </a:r>
+          </a:p>
+        </p:txBody>
+      </p:sp>
+      <p:sp>
+        <p:nvSpPr>
+          <p:cNvPr id="4" name="TextBox 3">
+            <a:extLst>
+              <a:ext uri="{FF2B5EF4-FFF2-40B4-BE49-F238E27FC236}">
+                <a16:creationId xmlns:a16="http://schemas.microsoft.com/office/drawing/2014/main" id="{EC928B0E-931C-E27B-9424-C24F07C7626C}"/>
+              </a:ext>
+            </a:extLst>
+          </p:cNvPr>
+          <p:cNvSpPr txBox="1"/>
+          <p:nvPr/>
+        </p:nvSpPr>
+        <p:spPr>
+          <a:xfrm>
+            <a:off x="838200" y="1156772"/>
+            <a:ext cx="10971881" cy="461665"/>
+          </a:xfrm>
+          <a:prstGeom prst="rect">
+            <a:avLst/>
+          </a:prstGeom>
+          <a:noFill/>
+        </p:spPr>
+        <p:txBody>
+          <a:bodyPr wrap="square" rtlCol="0">
+            <a:spAutoFit/>
+          </a:bodyPr>
+          <a:lstStyle/>
+          <a:p>
+            <a:r>
+              <a:rPr lang="en-US" sz="2400" dirty="0"/>
+              <a:t>The video/class demo uses separate inputs to prove different rubric requirements.</a:t>
+            </a:r>
+          </a:p>
+        </p:txBody>
+      </p:sp>
+      <p:sp>
+        <p:nvSpPr>
+          <p:cNvPr id="5" name="Rounded Rectangle 4">
+            <a:extLst>
+              <a:ext uri="{FF2B5EF4-FFF2-40B4-BE49-F238E27FC236}">
+                <a16:creationId xmlns:a16="http://schemas.microsoft.com/office/drawing/2014/main" id="{ABA4A58E-EDD3-A7E3-2557-584F8A1982BC}"/>
+              </a:ext>
+            </a:extLst>
+          </p:cNvPr>
+          <p:cNvSpPr/>
+          <p:nvPr/>
+        </p:nvSpPr>
+        <p:spPr>
+          <a:xfrm>
+            <a:off x="838200" y="1849265"/>
+            <a:ext cx="10971881" cy="1081221"/>
+          </a:xfrm>
+          <a:prstGeom prst="roundRect">
+            <a:avLst/>
+          </a:prstGeom>
+          <a:solidFill>
+            <a:schemeClr val="accent5">
+              <a:lumMod val="20000"/>
+              <a:lumOff val="80000"/>
+            </a:schemeClr>
+          </a:solidFill>
+          <a:ln>
+            <a:solidFill>
+              <a:schemeClr val="accent5">
+                <a:lumMod val="20000"/>
+                <a:lumOff val="80000"/>
+              </a:schemeClr>
+            </a:solidFill>
+          </a:ln>
+        </p:spPr>
+        <p:style>
+          <a:lnRef idx="2">
+            <a:schemeClr val="accent1">
+              <a:shade val="15000"/>
+            </a:schemeClr>
+          </a:lnRef>
+          <a:fillRef idx="1">
+            <a:schemeClr val="accent1"/>
+          </a:fillRef>
+          <a:effectRef idx="0">
+            <a:schemeClr val="accent1"/>
+          </a:effectRef>
+          <a:fontRef idx="minor">
+            <a:schemeClr val="lt1"/>
+          </a:fontRef>
+        </p:style>
+        <p:txBody>
+          <a:bodyPr rtlCol="0" anchor="ctr"/>
+          <a:lstStyle/>
+          <a:p>
+            <a:r>
+              <a:rPr lang="en-US" b="1" dirty="0">
+                <a:solidFill>
+                  <a:schemeClr val="tx1"/>
+                </a:solidFill>
+              </a:rPr>
+              <a:t>AI-assisted scheduling</a:t>
+            </a:r>
+          </a:p>
+          <a:p>
+            <a:r>
+              <a:rPr lang="en-US" dirty="0">
+                <a:solidFill>
+                  <a:schemeClr val="tx1"/>
+                </a:solidFill>
+              </a:rPr>
+              <a:t>“Schedule a 20-minute play session for Miso every day at 6:30 PM”</a:t>
+            </a:r>
+          </a:p>
+          <a:p>
+            <a:r>
+              <a:rPr lang="en-US" dirty="0">
+                <a:solidFill>
+                  <a:schemeClr val="tx1"/>
+                </a:solidFill>
+              </a:rPr>
+              <a:t>Shows natural-language </a:t>
+            </a:r>
+            <a:r>
+              <a:rPr lang="en-US" dirty="0">
+                <a:solidFill>
+                  <a:schemeClr val="tx1"/>
+                </a:solidFill>
+                <a:sym typeface="Wingdings" pitchFamily="2" charset="2"/>
+              </a:rPr>
+              <a:t> structured task  scheduler update</a:t>
+            </a:r>
+            <a:endParaRPr lang="en-US" dirty="0">
+              <a:solidFill>
+                <a:schemeClr val="tx1"/>
+              </a:solidFill>
+            </a:endParaRPr>
+          </a:p>
+        </p:txBody>
+      </p:sp>
+      <p:sp>
+        <p:nvSpPr>
+          <p:cNvPr id="6" name="Rounded Rectangle 5">
+            <a:extLst>
+              <a:ext uri="{FF2B5EF4-FFF2-40B4-BE49-F238E27FC236}">
+                <a16:creationId xmlns:a16="http://schemas.microsoft.com/office/drawing/2014/main" id="{2D000889-0844-928C-F222-663CDBAD5576}"/>
+              </a:ext>
+            </a:extLst>
+          </p:cNvPr>
+          <p:cNvSpPr/>
+          <p:nvPr/>
+        </p:nvSpPr>
+        <p:spPr>
+          <a:xfrm>
+            <a:off x="838200" y="3329847"/>
+            <a:ext cx="10971881" cy="1081221"/>
+          </a:xfrm>
+          <a:prstGeom prst="roundRect">
+            <a:avLst/>
+          </a:prstGeom>
+          <a:solidFill>
+            <a:schemeClr val="accent6">
+              <a:lumMod val="40000"/>
+              <a:lumOff val="60000"/>
+            </a:schemeClr>
+          </a:solidFill>
+          <a:ln>
+            <a:solidFill>
+              <a:schemeClr val="accent6">
+                <a:lumMod val="40000"/>
+                <a:lumOff val="60000"/>
+              </a:schemeClr>
+            </a:solidFill>
+          </a:ln>
+        </p:spPr>
+        <p:style>
+          <a:lnRef idx="2">
+            <a:schemeClr val="accent1">
+              <a:shade val="15000"/>
+            </a:schemeClr>
+          </a:lnRef>
+          <a:fillRef idx="1">
+            <a:schemeClr val="accent1"/>
+          </a:fillRef>
+          <a:effectRef idx="0">
+            <a:schemeClr val="accent1"/>
+          </a:effectRef>
+          <a:fontRef idx="minor">
+            <a:schemeClr val="lt1"/>
+          </a:fontRef>
+        </p:style>
+        <p:txBody>
+          <a:bodyPr rtlCol="0" anchor="ctr"/>
+          <a:lstStyle/>
+          <a:p>
+            <a:r>
+              <a:rPr lang="en-US" b="1" dirty="0">
+                <a:solidFill>
+                  <a:schemeClr val="tx1"/>
+                </a:solidFill>
+              </a:rPr>
+              <a:t>Grounded scheduling reasoning</a:t>
+            </a:r>
+          </a:p>
+          <a:p>
+            <a:r>
+              <a:rPr lang="en-US" dirty="0">
+                <a:solidFill>
+                  <a:schemeClr val="tx1"/>
+                </a:solidFill>
+              </a:rPr>
+              <a:t>“What should I focus on today for Nova?”</a:t>
+            </a:r>
+          </a:p>
+          <a:p>
+            <a:r>
+              <a:rPr lang="en-US" dirty="0">
+                <a:solidFill>
+                  <a:schemeClr val="tx1"/>
+                </a:solidFill>
+              </a:rPr>
+              <a:t>Shows retrieval over live schedule context and a schedule-aware response.</a:t>
+            </a:r>
+          </a:p>
+        </p:txBody>
+      </p:sp>
+      <p:sp>
+        <p:nvSpPr>
+          <p:cNvPr id="7" name="Rounded Rectangle 6">
+            <a:extLst>
+              <a:ext uri="{FF2B5EF4-FFF2-40B4-BE49-F238E27FC236}">
+                <a16:creationId xmlns:a16="http://schemas.microsoft.com/office/drawing/2014/main" id="{6644B144-051E-A146-0941-641BCBEFB759}"/>
+              </a:ext>
+            </a:extLst>
+          </p:cNvPr>
+          <p:cNvSpPr/>
+          <p:nvPr/>
+        </p:nvSpPr>
+        <p:spPr>
+          <a:xfrm>
+            <a:off x="838200" y="4810429"/>
+            <a:ext cx="10971881" cy="1081221"/>
+          </a:xfrm>
+          <a:prstGeom prst="roundRect">
+            <a:avLst/>
+          </a:prstGeom>
+          <a:solidFill>
+            <a:srgbClr val="EEB5AE"/>
+          </a:solidFill>
+          <a:ln>
+            <a:solidFill>
+              <a:srgbClr val="EEB5AE"/>
+            </a:solidFill>
+          </a:ln>
+        </p:spPr>
+        <p:style>
+          <a:lnRef idx="2">
+            <a:schemeClr val="accent1">
+              <a:shade val="15000"/>
+            </a:schemeClr>
+          </a:lnRef>
+          <a:fillRef idx="1">
+            <a:schemeClr val="accent1"/>
+          </a:fillRef>
+          <a:effectRef idx="0">
+            <a:schemeClr val="accent1"/>
+          </a:effectRef>
+          <a:fontRef idx="minor">
+            <a:schemeClr val="lt1"/>
+          </a:fontRef>
+        </p:style>
+        <p:txBody>
+          <a:bodyPr rtlCol="0" anchor="ctr"/>
+          <a:lstStyle/>
+          <a:p>
+            <a:r>
+              <a:rPr lang="en-US" b="1" dirty="0">
+                <a:solidFill>
+                  <a:schemeClr val="tx1"/>
+                </a:solidFill>
+              </a:rPr>
+              <a:t>Medical safety guardrail</a:t>
+            </a:r>
+          </a:p>
+          <a:p>
+            <a:r>
+              <a:rPr lang="en-US" dirty="0">
+                <a:solidFill>
+                  <a:schemeClr val="tx1"/>
+                </a:solidFill>
+              </a:rPr>
+              <a:t>“Miso is hiding, not eating, and having trouble breathing. What should I do?”</a:t>
+            </a:r>
+          </a:p>
+          <a:p>
+            <a:r>
+              <a:rPr lang="en-US" dirty="0">
+                <a:solidFill>
+                  <a:schemeClr val="tx1"/>
+                </a:solidFill>
+              </a:rPr>
+              <a:t>Shows emergency redirect instead of unsafe medical advice.</a:t>
+            </a:r>
+          </a:p>
+        </p:txBody>
+      </p:sp>
+      <p:sp>
+        <p:nvSpPr>
+          <p:cNvPr id="8" name="TextBox 7">
+            <a:extLst>
+              <a:ext uri="{FF2B5EF4-FFF2-40B4-BE49-F238E27FC236}">
+                <a16:creationId xmlns:a16="http://schemas.microsoft.com/office/drawing/2014/main" id="{49581695-B3B4-F90A-27E9-9844F9400140}"/>
+              </a:ext>
+            </a:extLst>
+          </p:cNvPr>
+          <p:cNvSpPr txBox="1"/>
+          <p:nvPr/>
+        </p:nvSpPr>
+        <p:spPr>
+          <a:xfrm>
+            <a:off x="512742" y="6159331"/>
+            <a:ext cx="11622796" cy="461665"/>
+          </a:xfrm>
+          <a:prstGeom prst="rect">
+            <a:avLst/>
+          </a:prstGeom>
+          <a:noFill/>
+        </p:spPr>
+        <p:txBody>
+          <a:bodyPr wrap="square" rtlCol="0">
+            <a:spAutoFit/>
+          </a:bodyPr>
+          <a:lstStyle/>
+          <a:p>
+            <a:r>
+              <a:rPr lang="en-US" sz="2400" b="1" dirty="0"/>
+              <a:t>Demo proves end-to-end execution, AI behavior, reliability behavior, clear outputs</a:t>
+            </a:r>
+          </a:p>
+        </p:txBody>
+      </p:sp>
+    </p:spTree>
+    <p:extLst>
+      <p:ext uri="{BB962C8B-B14F-4D97-AF65-F5344CB8AC3E}">
+        <p14:creationId xmlns:p14="http://schemas.microsoft.com/office/powerpoint/2010/main" val="1578494186"/>
+      </p:ext>
+    </p:extLst>
+  </p:cSld>
+  <p:clrMapOvr>
+    <a:masterClrMapping/>
+  </p:clrMapOvr>
+</p:sld>
+</file>
+
+<file path=ppt/slides/slide6.xml><?xml version="1.0" encoding="utf-8"?>
+<p:sld xmlns:a="http://schemas.openxmlformats.org/drawingml/2006/main" xmlns:r="http://schemas.openxmlformats.org/officeDocument/2006/relationships" xmlns:p="http://schemas.openxmlformats.org/presentationml/2006/main">
+  <p:cSld>
+    <p:spTree>
+      <p:nvGrpSpPr>
+        <p:cNvPr id="1" name=""/>
+        <p:cNvGrpSpPr/>
+        <p:nvPr/>
+      </p:nvGrpSpPr>
+      <p:grpSpPr>
+        <a:xfrm>
+          <a:off x="0" y="0"/>
+          <a:ext cx="0" cy="0"/>
+          <a:chOff x="0" y="0"/>
+          <a:chExt cx="0" cy="0"/>
+        </a:xfrm>
+      </p:grpSpPr>
+      <p:sp>
+        <p:nvSpPr>
+          <p:cNvPr id="2" name="Title 1">
+            <a:extLst>
+              <a:ext uri="{FF2B5EF4-FFF2-40B4-BE49-F238E27FC236}">
+                <a16:creationId xmlns:a16="http://schemas.microsoft.com/office/drawing/2014/main" id="{13F35BB1-3763-8CFF-20B0-66B050BAAB7A}"/>
+              </a:ext>
+            </a:extLst>
+          </p:cNvPr>
+          <p:cNvSpPr>
+            <a:spLocks noGrp="1"/>
+          </p:cNvSpPr>
+          <p:nvPr>
+            <p:ph type="title"/>
+          </p:nvPr>
+        </p:nvSpPr>
+        <p:spPr>
+          <a:xfrm>
+            <a:off x="838200" y="365125"/>
+            <a:ext cx="10515600" cy="703511"/>
+          </a:xfrm>
+        </p:spPr>
+        <p:txBody>
+          <a:bodyPr/>
+          <a:lstStyle/>
+          <a:p>
+            <a:r>
+              <a:rPr lang="en-US" dirty="0"/>
+              <a:t>Reliability and Evaluation</a:t>
+            </a:r>
+          </a:p>
+        </p:txBody>
+      </p:sp>
+      <p:sp>
+        <p:nvSpPr>
+          <p:cNvPr id="4" name="TextBox 3">
+            <a:extLst>
+              <a:ext uri="{FF2B5EF4-FFF2-40B4-BE49-F238E27FC236}">
+                <a16:creationId xmlns:a16="http://schemas.microsoft.com/office/drawing/2014/main" id="{A1D94635-2EA6-B82C-AAA5-0FEC720C338D}"/>
+              </a:ext>
+            </a:extLst>
+          </p:cNvPr>
+          <p:cNvSpPr txBox="1"/>
+          <p:nvPr/>
+        </p:nvSpPr>
+        <p:spPr>
+          <a:xfrm>
+            <a:off x="838200" y="1156772"/>
+            <a:ext cx="10971881" cy="461665"/>
+          </a:xfrm>
+          <a:prstGeom prst="rect">
+            <a:avLst/>
+          </a:prstGeom>
+          <a:noFill/>
+        </p:spPr>
+        <p:txBody>
+          <a:bodyPr wrap="square" rtlCol="0">
+            <a:spAutoFit/>
+          </a:bodyPr>
+          <a:lstStyle/>
+          <a:p>
+            <a:r>
+              <a:rPr lang="en-US" sz="2400" dirty="0"/>
+              <a:t>The project proves behavior through tests, guardrails, and visible failure handling.</a:t>
+            </a:r>
+          </a:p>
+        </p:txBody>
+      </p:sp>
+      <p:sp>
+        <p:nvSpPr>
+          <p:cNvPr id="5" name="Rounded Rectangle 4">
+            <a:extLst>
+              <a:ext uri="{FF2B5EF4-FFF2-40B4-BE49-F238E27FC236}">
+                <a16:creationId xmlns:a16="http://schemas.microsoft.com/office/drawing/2014/main" id="{BC18180C-F7C5-9C9E-8E38-79453F536D9F}"/>
+              </a:ext>
+            </a:extLst>
+          </p:cNvPr>
+          <p:cNvSpPr/>
+          <p:nvPr/>
+        </p:nvSpPr>
+        <p:spPr>
+          <a:xfrm>
+            <a:off x="177187" y="1871425"/>
+            <a:ext cx="3700749" cy="1557575"/>
+          </a:xfrm>
+          <a:prstGeom prst="roundRect">
+            <a:avLst/>
+          </a:prstGeom>
+          <a:solidFill>
+            <a:srgbClr val="EEB5AE"/>
+          </a:solidFill>
+          <a:ln>
+            <a:solidFill>
+              <a:srgbClr val="EEB5AE"/>
+            </a:solidFill>
+          </a:ln>
+        </p:spPr>
+        <p:style>
+          <a:lnRef idx="2">
+            <a:schemeClr val="accent1">
+              <a:shade val="15000"/>
+            </a:schemeClr>
+          </a:lnRef>
+          <a:fillRef idx="1">
+            <a:schemeClr val="accent1"/>
+          </a:fillRef>
+          <a:effectRef idx="0">
+            <a:schemeClr val="accent1"/>
+          </a:effectRef>
+          <a:fontRef idx="minor">
+            <a:schemeClr val="lt1"/>
+          </a:fontRef>
+        </p:style>
+        <p:txBody>
+          <a:bodyPr rtlCol="0" anchor="ctr"/>
+          <a:lstStyle/>
+          <a:p>
+            <a:r>
+              <a:rPr lang="en-US" b="1" dirty="0">
+                <a:solidFill>
+                  <a:schemeClr val="tx1"/>
+                </a:solidFill>
+              </a:rPr>
+              <a:t>Guardrails</a:t>
+            </a:r>
+          </a:p>
+          <a:p>
+            <a:r>
+              <a:rPr lang="en-US" dirty="0">
+                <a:solidFill>
+                  <a:schemeClr val="tx1"/>
+                </a:solidFill>
+              </a:rPr>
+              <a:t>Prompt-injection checks, medical emergency redirect, input + task validation, iteration cap</a:t>
+            </a:r>
+          </a:p>
+        </p:txBody>
+      </p:sp>
+      <p:sp>
+        <p:nvSpPr>
+          <p:cNvPr id="6" name="Rounded Rectangle 5">
+            <a:extLst>
+              <a:ext uri="{FF2B5EF4-FFF2-40B4-BE49-F238E27FC236}">
+                <a16:creationId xmlns:a16="http://schemas.microsoft.com/office/drawing/2014/main" id="{A6129B2B-4525-7FDF-6A41-DA0375704D02}"/>
+              </a:ext>
+            </a:extLst>
+          </p:cNvPr>
+          <p:cNvSpPr/>
+          <p:nvPr/>
+        </p:nvSpPr>
+        <p:spPr>
+          <a:xfrm>
+            <a:off x="4268117" y="1871424"/>
+            <a:ext cx="3700749" cy="1557575"/>
+          </a:xfrm>
+          <a:prstGeom prst="roundRect">
+            <a:avLst/>
+          </a:prstGeom>
+          <a:solidFill>
+            <a:schemeClr val="accent4">
+              <a:lumMod val="20000"/>
+              <a:lumOff val="80000"/>
+            </a:schemeClr>
+          </a:solidFill>
+          <a:ln>
+            <a:solidFill>
+              <a:schemeClr val="accent4">
+                <a:lumMod val="20000"/>
+                <a:lumOff val="80000"/>
+              </a:schemeClr>
+            </a:solidFill>
+          </a:ln>
+        </p:spPr>
+        <p:style>
+          <a:lnRef idx="2">
+            <a:schemeClr val="accent1">
+              <a:shade val="15000"/>
+            </a:schemeClr>
+          </a:lnRef>
+          <a:fillRef idx="1">
+            <a:schemeClr val="accent1"/>
+          </a:fillRef>
+          <a:effectRef idx="0">
+            <a:schemeClr val="accent1"/>
+          </a:effectRef>
+          <a:fontRef idx="minor">
+            <a:schemeClr val="lt1"/>
+          </a:fontRef>
+        </p:style>
+        <p:txBody>
+          <a:bodyPr rtlCol="0" anchor="ctr"/>
+          <a:lstStyle/>
+          <a:p>
+            <a:r>
+              <a:rPr lang="en-US" b="1" dirty="0">
+                <a:solidFill>
+                  <a:schemeClr val="tx1"/>
+                </a:solidFill>
+              </a:rPr>
+              <a:t>Structured behavior</a:t>
+            </a:r>
+          </a:p>
+          <a:p>
+            <a:r>
+              <a:rPr lang="en-US" dirty="0">
+                <a:solidFill>
+                  <a:schemeClr val="tx1"/>
+                </a:solidFill>
+              </a:rPr>
+              <a:t>JSON task proposals, confidence score, self-critique, observable trace</a:t>
+            </a:r>
+          </a:p>
+        </p:txBody>
+      </p:sp>
+      <p:sp>
+        <p:nvSpPr>
+          <p:cNvPr id="7" name="Rounded Rectangle 6">
+            <a:extLst>
+              <a:ext uri="{FF2B5EF4-FFF2-40B4-BE49-F238E27FC236}">
+                <a16:creationId xmlns:a16="http://schemas.microsoft.com/office/drawing/2014/main" id="{F96A4F33-39BB-AAC1-1B74-D7092E83F9A1}"/>
+              </a:ext>
+            </a:extLst>
+          </p:cNvPr>
+          <p:cNvSpPr/>
+          <p:nvPr/>
+        </p:nvSpPr>
+        <p:spPr>
+          <a:xfrm>
+            <a:off x="8359047" y="1871424"/>
+            <a:ext cx="3700749" cy="1557575"/>
+          </a:xfrm>
+          <a:prstGeom prst="roundRect">
+            <a:avLst/>
+          </a:prstGeom>
+          <a:solidFill>
+            <a:schemeClr val="accent6">
+              <a:lumMod val="20000"/>
+              <a:lumOff val="80000"/>
+            </a:schemeClr>
+          </a:solidFill>
+          <a:ln>
+            <a:solidFill>
+              <a:schemeClr val="accent6">
+                <a:lumMod val="20000"/>
+                <a:lumOff val="80000"/>
+              </a:schemeClr>
+            </a:solidFill>
+          </a:ln>
+        </p:spPr>
+        <p:style>
+          <a:lnRef idx="2">
+            <a:schemeClr val="accent1">
+              <a:shade val="15000"/>
+            </a:schemeClr>
+          </a:lnRef>
+          <a:fillRef idx="1">
+            <a:schemeClr val="accent1"/>
+          </a:fillRef>
+          <a:effectRef idx="0">
+            <a:schemeClr val="accent1"/>
+          </a:effectRef>
+          <a:fontRef idx="minor">
+            <a:schemeClr val="lt1"/>
+          </a:fontRef>
+        </p:style>
+        <p:txBody>
+          <a:bodyPr rtlCol="0" anchor="ctr"/>
+          <a:lstStyle/>
+          <a:p>
+            <a:r>
+              <a:rPr lang="en-US" b="1" dirty="0">
+                <a:solidFill>
+                  <a:schemeClr val="tx1"/>
+                </a:solidFill>
+              </a:rPr>
+              <a:t>Testing</a:t>
+            </a:r>
+          </a:p>
+          <a:p>
+            <a:r>
+              <a:rPr lang="en-US" dirty="0">
+                <a:solidFill>
+                  <a:schemeClr val="tx1"/>
+                </a:solidFill>
+              </a:rPr>
+              <a:t>pytest, evaluation harness, 10+ scenarios, pass/fail summary</a:t>
+            </a:r>
+          </a:p>
+        </p:txBody>
+      </p:sp>
+      <p:sp>
+        <p:nvSpPr>
+          <p:cNvPr id="8" name="Rounded Rectangle 7">
+            <a:extLst>
+              <a:ext uri="{FF2B5EF4-FFF2-40B4-BE49-F238E27FC236}">
+                <a16:creationId xmlns:a16="http://schemas.microsoft.com/office/drawing/2014/main" id="{344325B9-FBFD-567B-4EFC-3B55F202B7DB}"/>
+              </a:ext>
+            </a:extLst>
+          </p:cNvPr>
+          <p:cNvSpPr/>
+          <p:nvPr/>
+        </p:nvSpPr>
+        <p:spPr>
+          <a:xfrm>
+            <a:off x="302044" y="4231788"/>
+            <a:ext cx="11632894" cy="1164123"/>
+          </a:xfrm>
+          <a:prstGeom prst="roundRect">
+            <a:avLst/>
+          </a:prstGeom>
+          <a:noFill/>
+          <a:ln>
+            <a:solidFill>
+              <a:schemeClr val="bg1">
+                <a:lumMod val="65000"/>
+              </a:schemeClr>
+            </a:solidFill>
+          </a:ln>
+        </p:spPr>
+        <p:style>
+          <a:lnRef idx="2">
+            <a:schemeClr val="accent1">
+              <a:shade val="15000"/>
+            </a:schemeClr>
+          </a:lnRef>
+          <a:fillRef idx="1">
+            <a:schemeClr val="accent1"/>
+          </a:fillRef>
+          <a:effectRef idx="0">
+            <a:schemeClr val="accent1"/>
+          </a:effectRef>
+          <a:fontRef idx="minor">
+            <a:schemeClr val="lt1"/>
+          </a:fontRef>
+        </p:style>
+        <p:txBody>
+          <a:bodyPr rtlCol="0" anchor="ctr"/>
+          <a:lstStyle/>
+          <a:p>
+            <a:r>
+              <a:rPr lang="en-US" b="1" dirty="0">
+                <a:solidFill>
+                  <a:srgbClr val="FF0000"/>
+                </a:solidFill>
+              </a:rPr>
+              <a:t>Example guardrail output</a:t>
+            </a:r>
+          </a:p>
+          <a:p>
+            <a:r>
+              <a:rPr lang="en-US" i="1" dirty="0">
+                <a:solidFill>
+                  <a:schemeClr val="tx1"/>
+                </a:solidFill>
+              </a:rPr>
+              <a:t>”This may be an emergency. Please contact a veterinarian or emergency clinic immediately. I can help organize follow-up tasks, but I should not diagnose or prescribe treatment.”</a:t>
+            </a:r>
+          </a:p>
+        </p:txBody>
+      </p:sp>
+    </p:spTree>
+    <p:extLst>
+      <p:ext uri="{BB962C8B-B14F-4D97-AF65-F5344CB8AC3E}">
+        <p14:creationId xmlns:p14="http://schemas.microsoft.com/office/powerpoint/2010/main" val="2360908529"/>
+      </p:ext>
+    </p:extLst>
+  </p:cSld>
+  <p:clrMapOvr>
+    <a:masterClrMapping/>
+  </p:clrMapOvr>
+</p:sld>
+</file>
+
+<file path=ppt/slides/slide7.xml><?xml version="1.0" encoding="utf-8"?>
+<p:sld xmlns:a="http://schemas.openxmlformats.org/drawingml/2006/main" xmlns:r="http://schemas.openxmlformats.org/officeDocument/2006/relationships" xmlns:p="http://schemas.openxmlformats.org/presentationml/2006/main">
+  <p:cSld>
+    <p:spTree>
+      <p:nvGrpSpPr>
+        <p:cNvPr id="1" name=""/>
+        <p:cNvGrpSpPr/>
+        <p:nvPr/>
+      </p:nvGrpSpPr>
+      <p:grpSpPr>
+        <a:xfrm>
+          <a:off x="0" y="0"/>
+          <a:ext cx="0" cy="0"/>
+          <a:chOff x="0" y="0"/>
+          <a:chExt cx="0" cy="0"/>
+        </a:xfrm>
+      </p:grpSpPr>
+      <p:sp>
+        <p:nvSpPr>
+          <p:cNvPr id="2" name="Title 1">
+            <a:extLst>
+              <a:ext uri="{FF2B5EF4-FFF2-40B4-BE49-F238E27FC236}">
+                <a16:creationId xmlns:a16="http://schemas.microsoft.com/office/drawing/2014/main" id="{D002B104-7D69-E344-12D4-09F15C26B2DA}"/>
+              </a:ext>
+            </a:extLst>
+          </p:cNvPr>
+          <p:cNvSpPr>
+            <a:spLocks noGrp="1"/>
+          </p:cNvSpPr>
+          <p:nvPr>
+            <p:ph type="title"/>
+          </p:nvPr>
+        </p:nvSpPr>
+        <p:spPr>
+          <a:xfrm>
+            <a:off x="838200" y="365125"/>
+            <a:ext cx="10515600" cy="857747"/>
+          </a:xfrm>
+        </p:spPr>
+        <p:txBody>
+          <a:bodyPr/>
+          <a:lstStyle/>
+          <a:p>
+            <a:r>
+              <a:rPr lang="en-US" dirty="0"/>
+              <a:t>Reflection: What I learned</a:t>
+            </a:r>
+          </a:p>
+        </p:txBody>
+      </p:sp>
+      <p:sp>
+        <p:nvSpPr>
+          <p:cNvPr id="4" name="TextBox 3">
+            <a:extLst>
+              <a:ext uri="{FF2B5EF4-FFF2-40B4-BE49-F238E27FC236}">
+                <a16:creationId xmlns:a16="http://schemas.microsoft.com/office/drawing/2014/main" id="{0668D942-45C1-10C5-DBC9-85C661E1857A}"/>
+              </a:ext>
+            </a:extLst>
+          </p:cNvPr>
+          <p:cNvSpPr txBox="1"/>
+          <p:nvPr/>
+        </p:nvSpPr>
+        <p:spPr>
+          <a:xfrm>
+            <a:off x="838200" y="1156772"/>
+            <a:ext cx="10971881" cy="461665"/>
+          </a:xfrm>
+          <a:prstGeom prst="rect">
+            <a:avLst/>
+          </a:prstGeom>
+          <a:noFill/>
+        </p:spPr>
+        <p:txBody>
+          <a:bodyPr wrap="square" rtlCol="0">
+            <a:spAutoFit/>
+          </a:bodyPr>
+          <a:lstStyle/>
+          <a:p>
+            <a:r>
+              <a:rPr lang="en-US" sz="2400" dirty="0"/>
+              <a:t>AI engineering is product design + software architecture + evaluation.</a:t>
+            </a:r>
+          </a:p>
+        </p:txBody>
+      </p:sp>
+      <p:sp>
+        <p:nvSpPr>
+          <p:cNvPr id="5" name="Rounded Rectangle 4">
+            <a:extLst>
+              <a:ext uri="{FF2B5EF4-FFF2-40B4-BE49-F238E27FC236}">
+                <a16:creationId xmlns:a16="http://schemas.microsoft.com/office/drawing/2014/main" id="{0595EE4B-9DE9-12BD-1387-380354DB37BB}"/>
+              </a:ext>
+            </a:extLst>
+          </p:cNvPr>
+          <p:cNvSpPr/>
+          <p:nvPr/>
+        </p:nvSpPr>
+        <p:spPr>
+          <a:xfrm>
+            <a:off x="838200" y="1849266"/>
+            <a:ext cx="10971881" cy="706648"/>
+          </a:xfrm>
+          <a:prstGeom prst="roundRect">
+            <a:avLst/>
+          </a:prstGeom>
+          <a:solidFill>
+            <a:schemeClr val="accent4">
+              <a:lumMod val="40000"/>
+              <a:lumOff val="60000"/>
+            </a:schemeClr>
+          </a:solidFill>
+          <a:ln>
+            <a:solidFill>
+              <a:schemeClr val="accent4">
+                <a:lumMod val="40000"/>
+                <a:lumOff val="60000"/>
+              </a:schemeClr>
+            </a:solidFill>
+          </a:ln>
+        </p:spPr>
+        <p:style>
+          <a:lnRef idx="2">
+            <a:schemeClr val="accent1">
+              <a:shade val="15000"/>
+            </a:schemeClr>
+          </a:lnRef>
+          <a:fillRef idx="1">
+            <a:schemeClr val="accent1"/>
+          </a:fillRef>
+          <a:effectRef idx="0">
+            <a:schemeClr val="accent1"/>
+          </a:effectRef>
+          <a:fontRef idx="minor">
+            <a:schemeClr val="lt1"/>
+          </a:fontRef>
+        </p:style>
+        <p:txBody>
+          <a:bodyPr rtlCol="0" anchor="ctr"/>
+          <a:lstStyle/>
+          <a:p>
+            <a:r>
+              <a:rPr lang="en-US" b="1" dirty="0">
+                <a:solidFill>
+                  <a:schemeClr val="tx1"/>
+                </a:solidFill>
+              </a:rPr>
+              <a:t>AI needs system integration</a:t>
+            </a:r>
+          </a:p>
+          <a:p>
+            <a:r>
+              <a:rPr lang="en-US" dirty="0">
+                <a:solidFill>
+                  <a:schemeClr val="tx1"/>
+                </a:solidFill>
+              </a:rPr>
+              <a:t>The value comes from combining retrieval, tools, UI, storage, and evaluation.</a:t>
+            </a:r>
+          </a:p>
+        </p:txBody>
+      </p:sp>
+      <p:sp>
+        <p:nvSpPr>
+          <p:cNvPr id="6" name="Rounded Rectangle 5">
+            <a:extLst>
+              <a:ext uri="{FF2B5EF4-FFF2-40B4-BE49-F238E27FC236}">
+                <a16:creationId xmlns:a16="http://schemas.microsoft.com/office/drawing/2014/main" id="{6CADC0F8-83FF-A346-1320-CDAEAE9E07C6}"/>
+              </a:ext>
+            </a:extLst>
+          </p:cNvPr>
+          <p:cNvSpPr/>
+          <p:nvPr/>
+        </p:nvSpPr>
+        <p:spPr>
+          <a:xfrm>
+            <a:off x="838199" y="2976524"/>
+            <a:ext cx="10971881" cy="706648"/>
+          </a:xfrm>
+          <a:prstGeom prst="roundRect">
+            <a:avLst/>
+          </a:prstGeom>
+          <a:solidFill>
+            <a:srgbClr val="EEB5AE"/>
+          </a:solidFill>
+          <a:ln>
+            <a:solidFill>
+              <a:srgbClr val="EEB5AE"/>
+            </a:solidFill>
+          </a:ln>
+        </p:spPr>
+        <p:style>
+          <a:lnRef idx="2">
+            <a:schemeClr val="accent1">
+              <a:shade val="15000"/>
+            </a:schemeClr>
+          </a:lnRef>
+          <a:fillRef idx="1">
+            <a:schemeClr val="accent1"/>
+          </a:fillRef>
+          <a:effectRef idx="0">
+            <a:schemeClr val="accent1"/>
+          </a:effectRef>
+          <a:fontRef idx="minor">
+            <a:schemeClr val="lt1"/>
+          </a:fontRef>
+        </p:style>
+        <p:txBody>
+          <a:bodyPr rtlCol="0" anchor="ctr"/>
+          <a:lstStyle/>
+          <a:p>
+            <a:r>
+              <a:rPr lang="en-US" b="1" dirty="0">
+                <a:solidFill>
+                  <a:schemeClr val="tx1"/>
+                </a:solidFill>
+              </a:rPr>
+              <a:t>Reliability is a feature</a:t>
+            </a:r>
+          </a:p>
+          <a:p>
+            <a:r>
+              <a:rPr lang="en-US" dirty="0">
+                <a:solidFill>
+                  <a:schemeClr val="tx1"/>
+                </a:solidFill>
+              </a:rPr>
+              <a:t>Guardrails, validation, and tests matter as much as generating an answer.</a:t>
+            </a:r>
+          </a:p>
+        </p:txBody>
+      </p:sp>
+      <p:sp>
+        <p:nvSpPr>
+          <p:cNvPr id="7" name="Rounded Rectangle 6">
+            <a:extLst>
+              <a:ext uri="{FF2B5EF4-FFF2-40B4-BE49-F238E27FC236}">
+                <a16:creationId xmlns:a16="http://schemas.microsoft.com/office/drawing/2014/main" id="{0AC1B126-9764-326F-8F1D-E2716C014505}"/>
+              </a:ext>
+            </a:extLst>
+          </p:cNvPr>
+          <p:cNvSpPr/>
+          <p:nvPr/>
+        </p:nvSpPr>
+        <p:spPr>
+          <a:xfrm>
+            <a:off x="838198" y="4103782"/>
+            <a:ext cx="10971881" cy="706648"/>
+          </a:xfrm>
+          <a:prstGeom prst="roundRect">
+            <a:avLst/>
+          </a:prstGeom>
+          <a:solidFill>
+            <a:schemeClr val="accent6">
+              <a:lumMod val="40000"/>
+              <a:lumOff val="60000"/>
+            </a:schemeClr>
+          </a:solidFill>
+          <a:ln>
+            <a:solidFill>
+              <a:schemeClr val="accent6">
+                <a:lumMod val="40000"/>
+                <a:lumOff val="60000"/>
+              </a:schemeClr>
+            </a:solidFill>
+          </a:ln>
+        </p:spPr>
+        <p:style>
+          <a:lnRef idx="2">
+            <a:schemeClr val="accent1">
+              <a:shade val="15000"/>
+            </a:schemeClr>
+          </a:lnRef>
+          <a:fillRef idx="1">
+            <a:schemeClr val="accent1"/>
+          </a:fillRef>
+          <a:effectRef idx="0">
+            <a:schemeClr val="accent1"/>
+          </a:effectRef>
+          <a:fontRef idx="minor">
+            <a:schemeClr val="lt1"/>
+          </a:fontRef>
+        </p:style>
+        <p:txBody>
+          <a:bodyPr rtlCol="0" anchor="ctr"/>
+          <a:lstStyle/>
+          <a:p>
+            <a:r>
+              <a:rPr lang="en-US" b="1" dirty="0">
+                <a:solidFill>
+                  <a:schemeClr val="tx1"/>
+                </a:solidFill>
+              </a:rPr>
+              <a:t>Model flexibility matters</a:t>
+            </a:r>
+          </a:p>
+          <a:p>
+            <a:r>
+              <a:rPr lang="en-US" dirty="0">
+                <a:solidFill>
+                  <a:schemeClr val="tx1"/>
+                </a:solidFill>
+              </a:rPr>
+              <a:t>TF-IDF, Gemini, and Ollama show different privacy, cost latency, and deployment tradeoffs.</a:t>
+            </a:r>
+          </a:p>
+        </p:txBody>
+      </p:sp>
+      <p:sp>
+        <p:nvSpPr>
+          <p:cNvPr id="8" name="TextBox 7">
+            <a:extLst>
+              <a:ext uri="{FF2B5EF4-FFF2-40B4-BE49-F238E27FC236}">
+                <a16:creationId xmlns:a16="http://schemas.microsoft.com/office/drawing/2014/main" id="{F37D4938-977A-6EF6-F1C3-079951A7187A}"/>
+              </a:ext>
+            </a:extLst>
+          </p:cNvPr>
+          <p:cNvSpPr txBox="1"/>
+          <p:nvPr/>
+        </p:nvSpPr>
+        <p:spPr>
+          <a:xfrm>
+            <a:off x="512740" y="5285729"/>
+            <a:ext cx="11622796" cy="1200329"/>
+          </a:xfrm>
+          <a:prstGeom prst="rect">
+            <a:avLst/>
+          </a:prstGeom>
+          <a:noFill/>
+        </p:spPr>
+        <p:txBody>
+          <a:bodyPr wrap="square" rtlCol="0">
+            <a:spAutoFit/>
+          </a:bodyPr>
+          <a:lstStyle/>
+          <a:p>
+            <a:r>
+              <a:rPr lang="en-US" sz="2400" b="1" dirty="0"/>
+              <a:t>Takeaway</a:t>
+            </a:r>
+          </a:p>
+          <a:p>
+            <a:r>
+              <a:rPr lang="en-US" sz="2400" dirty="0"/>
+              <a:t>I can take a traditional application and redesign it into a production-minded AI system with retrieval, agent workflows, guardrails, model choice, and evaluation.</a:t>
+            </a:r>
+          </a:p>
+        </p:txBody>
+      </p:sp>
+    </p:spTree>
+    <p:extLst>
+      <p:ext uri="{BB962C8B-B14F-4D97-AF65-F5344CB8AC3E}">
+        <p14:creationId xmlns:p14="http://schemas.microsoft.com/office/powerpoint/2010/main" val="2108855548"/>
       </p:ext>
     </p:extLst>
   </p:cSld>

</xml_diff>